<commit_message>
Feat: Add interactive Streamlit web dashboard app.py with live compression engine, flowchart, tables, and graphs
</commit_message>
<xml_diff>
--- a/docs/PRESENTATION_SLIDES.pptx
+++ b/docs/PRESENTATION_SLIDES.pptx
@@ -4,21 +4,24 @@
   <p:sldMasterIdLst>
     <p:sldMasterId id="2147483648" r:id="rId1"/>
   </p:sldMasterIdLst>
+  <p:notesMasterIdLst>
+    <p:notesMasterId r:id="rId14"/>
+  </p:notesMasterIdLst>
   <p:sldIdLst>
-    <p:sldId id="256" r:id="rId7"/>
-    <p:sldId id="257" r:id="rId9"/>
-    <p:sldId id="258" r:id="rId10"/>
-    <p:sldId id="259" r:id="rId11"/>
-    <p:sldId id="260" r:id="rId12"/>
-    <p:sldId id="261" r:id="rId13"/>
-    <p:sldId id="262" r:id="rId14"/>
-    <p:sldId id="263" r:id="rId15"/>
-    <p:sldId id="264" r:id="rId16"/>
-    <p:sldId id="265" r:id="rId17"/>
-    <p:sldId id="266" r:id="rId18"/>
-    <p:sldId id="267" r:id="rId19"/>
+    <p:sldId id="256" r:id="rId2"/>
+    <p:sldId id="257" r:id="rId3"/>
+    <p:sldId id="258" r:id="rId4"/>
+    <p:sldId id="259" r:id="rId5"/>
+    <p:sldId id="260" r:id="rId6"/>
+    <p:sldId id="261" r:id="rId7"/>
+    <p:sldId id="262" r:id="rId8"/>
+    <p:sldId id="263" r:id="rId9"/>
+    <p:sldId id="264" r:id="rId10"/>
+    <p:sldId id="265" r:id="rId11"/>
+    <p:sldId id="266" r:id="rId12"/>
+    <p:sldId id="267" r:id="rId13"/>
   </p:sldIdLst>
-  <p:sldSz cx="12191695" cy="6858000" type="screen4x3"/>
+  <p:sldSz cx="12192000" cy="6858000"/>
   <p:notesSz cx="6858000" cy="9144000"/>
   <p:defaultTextStyle>
     <a:defPPr>
@@ -115,11 +118,27 @@
       </a:defRPr>
     </a:lvl9pPr>
   </p:defaultTextStyle>
+  <p:extLst>
+    <p:ext uri="{EFAFB233-063F-42B5-8137-9DF3F51BA10A}">
+      <p15:sldGuideLst xmlns:p15="http://schemas.microsoft.com/office/powerpoint/2012/main">
+        <p15:guide id="1" orient="horz" pos="2160">
+          <p15:clr>
+            <a:srgbClr val="A4A3A4"/>
+          </p15:clr>
+        </p15:guide>
+        <p15:guide id="2" pos="2880">
+          <p15:clr>
+            <a:srgbClr val="A4A3A4"/>
+          </p15:clr>
+        </p15:guide>
+      </p15:sldGuideLst>
+    </p:ext>
+  </p:extLst>
 </p:presentation>
 </file>
 
 <file path=ppt/notesMasters/notesMaster1.xml><?xml version="1.0" encoding="utf-8"?>
-<p:notesMaster xmlns:a="http://schemas.openxmlformats.org/drawingml/2006/main" xmlns:p="http://schemas.openxmlformats.org/presentationml/2006/main" xmlns:r="http://schemas.openxmlformats.org/officeDocument/2006/relationships">
+<p:notesMaster xmlns:a="http://schemas.openxmlformats.org/drawingml/2006/main" xmlns:r="http://schemas.openxmlformats.org/officeDocument/2006/relationships" xmlns:p="http://schemas.openxmlformats.org/presentationml/2006/main">
   <p:cSld>
     <p:bg>
       <p:bgRef idx="1001">
@@ -140,241 +159,16 @@
           <a:chExt cx="0" cy="0"/>
         </a:xfrm>
       </p:grpSpPr>
-      <p:sp>
-        <p:nvSpPr>
-          <p:cNvPr id="2" name="Header Placeholder 1"/>
-          <p:cNvSpPr>
-            <a:spLocks noGrp="1"/>
-          </p:cNvSpPr>
-          <p:nvPr>
-            <p:ph type="hdr" sz="quarter"/>
-          </p:nvPr>
-        </p:nvSpPr>
-        <p:spPr>
-          <a:xfrm>
-            <a:off x="0" y="0"/>
-            <a:ext cx="2971800" cy="457200"/>
-          </a:xfrm>
-          <a:prstGeom prst="rect">
-            <a:avLst/>
-          </a:prstGeom>
-        </p:spPr>
-        <p:txBody>
-          <a:bodyPr vert="horz" lIns="91440" tIns="45720" rIns="91440" bIns="45720" rtlCol="0"/>
-          <a:lstStyle>
-            <a:lvl1pPr algn="l">
-              <a:defRPr sz="1200"/>
-            </a:lvl1pPr>
-          </a:lstStyle>
-          <a:p>
-            <a:endParaRPr lang="en-US"/>
-          </a:p>
-        </p:txBody>
-      </p:sp>
-      <p:sp>
-        <p:nvSpPr>
-          <p:cNvPr id="3" name="Date Placeholder 2"/>
-          <p:cNvSpPr>
-            <a:spLocks noGrp="1"/>
-          </p:cNvSpPr>
-          <p:nvPr>
-            <p:ph type="dt" idx="1"/>
-          </p:nvPr>
-        </p:nvSpPr>
-        <p:spPr>
-          <a:xfrm>
-            <a:off x="3884613" y="0"/>
-            <a:ext cx="2971800" cy="457200"/>
-          </a:xfrm>
-          <a:prstGeom prst="rect">
-            <a:avLst/>
-          </a:prstGeom>
-        </p:spPr>
-        <p:txBody>
-          <a:bodyPr vert="horz" lIns="91440" tIns="45720" rIns="91440" bIns="45720" rtlCol="0"/>
-          <a:lstStyle>
-            <a:lvl1pPr algn="r">
-              <a:defRPr sz="1200"/>
-            </a:lvl1pPr>
-          </a:lstStyle>
-          <a:p>
-            <a:fld id="{0F89C1C7-3DCD-1040-A9CF-14679D8B5DDD}" type="datetimeFigureOut">
-              <a:rPr lang="en-US" smtClean="0"/>
-              <a:t>10/17/16</a:t>
-            </a:fld>
-            <a:endParaRPr lang="en-US"/>
-          </a:p>
-        </p:txBody>
-      </p:sp>
-      <p:sp>
-        <p:nvSpPr>
-          <p:cNvPr id="4" name="Slide Image Placeholder 3"/>
-          <p:cNvSpPr>
-            <a:spLocks noGrp="1" noRot="1" noChangeAspect="1"/>
-          </p:cNvSpPr>
-          <p:nvPr>
-            <p:ph type="sldImg" idx="2"/>
-          </p:nvPr>
-        </p:nvSpPr>
-        <p:spPr>
-          <a:xfrm>
-            <a:off x="1143000" y="685800"/>
-            <a:ext cx="4572000" cy="3429000"/>
-          </a:xfrm>
-          <a:prstGeom prst="rect">
-            <a:avLst/>
-          </a:prstGeom>
-          <a:noFill/>
-          <a:ln w="12700">
-            <a:solidFill>
-              <a:prstClr val="black"/>
-            </a:solidFill>
-          </a:ln>
-        </p:spPr>
-        <p:txBody>
-          <a:bodyPr vert="horz" lIns="91440" tIns="45720" rIns="91440" bIns="45720" rtlCol="0" anchor="ctr"/>
-          <a:lstStyle/>
-          <a:p>
-            <a:endParaRPr lang="en-US"/>
-          </a:p>
-        </p:txBody>
-      </p:sp>
-      <p:sp>
-        <p:nvSpPr>
-          <p:cNvPr id="5" name="Notes Placeholder 4"/>
-          <p:cNvSpPr>
-            <a:spLocks noGrp="1"/>
-          </p:cNvSpPr>
-          <p:nvPr>
-            <p:ph type="body" sz="quarter" idx="3"/>
-          </p:nvPr>
-        </p:nvSpPr>
-        <p:spPr>
-          <a:xfrm>
-            <a:off x="685800" y="4343400"/>
-            <a:ext cx="5486400" cy="4114800"/>
-          </a:xfrm>
-          <a:prstGeom prst="rect">
-            <a:avLst/>
-          </a:prstGeom>
-        </p:spPr>
-        <p:txBody>
-          <a:bodyPr vert="horz" lIns="91440" tIns="45720" rIns="91440" bIns="45720" rtlCol="0"/>
-          <a:lstStyle/>
-          <a:p>
-            <a:pPr lvl="0"/>
-            <a:r>
-              <a:rPr lang="en-US" smtClean="0"/>
-              <a:t>Click to edit Master text styles</a:t>
-            </a:r>
-          </a:p>
-          <a:p>
-            <a:pPr lvl="1"/>
-            <a:r>
-              <a:rPr lang="en-US" smtClean="0"/>
-              <a:t>Second level</a:t>
-            </a:r>
-          </a:p>
-          <a:p>
-            <a:pPr lvl="2"/>
-            <a:r>
-              <a:rPr lang="en-US" smtClean="0"/>
-              <a:t>Third level</a:t>
-            </a:r>
-          </a:p>
-          <a:p>
-            <a:pPr lvl="3"/>
-            <a:r>
-              <a:rPr lang="en-US" smtClean="0"/>
-              <a:t>Fourth level</a:t>
-            </a:r>
-          </a:p>
-          <a:p>
-            <a:pPr lvl="4"/>
-            <a:r>
-              <a:rPr lang="en-US" smtClean="0"/>
-              <a:t>Fifth level</a:t>
-            </a:r>
-            <a:endParaRPr lang="en-US"/>
-          </a:p>
-        </p:txBody>
-      </p:sp>
-      <p:sp>
-        <p:nvSpPr>
-          <p:cNvPr id="6" name="Footer Placeholder 5"/>
-          <p:cNvSpPr>
-            <a:spLocks noGrp="1"/>
-          </p:cNvSpPr>
-          <p:nvPr>
-            <p:ph type="ftr" sz="quarter" idx="4"/>
-          </p:nvPr>
-        </p:nvSpPr>
-        <p:spPr>
-          <a:xfrm>
-            <a:off x="0" y="8685213"/>
-            <a:ext cx="2971800" cy="457200"/>
-          </a:xfrm>
-          <a:prstGeom prst="rect">
-            <a:avLst/>
-          </a:prstGeom>
-        </p:spPr>
-        <p:txBody>
-          <a:bodyPr vert="horz" lIns="91440" tIns="45720" rIns="91440" bIns="45720" rtlCol="0" anchor="b"/>
-          <a:lstStyle>
-            <a:lvl1pPr algn="l">
-              <a:defRPr sz="1200"/>
-            </a:lvl1pPr>
-          </a:lstStyle>
-          <a:p>
-            <a:endParaRPr lang="en-US"/>
-          </a:p>
-        </p:txBody>
-      </p:sp>
-      <p:sp>
-        <p:nvSpPr>
-          <p:cNvPr id="7" name="Slide Number Placeholder 6"/>
-          <p:cNvSpPr>
-            <a:spLocks noGrp="1"/>
-          </p:cNvSpPr>
-          <p:nvPr>
-            <p:ph type="sldNum" sz="quarter" idx="5"/>
-          </p:nvPr>
-        </p:nvSpPr>
-        <p:spPr>
-          <a:xfrm>
-            <a:off x="3884613" y="8685213"/>
-            <a:ext cx="2971800" cy="457200"/>
-          </a:xfrm>
-          <a:prstGeom prst="rect">
-            <a:avLst/>
-          </a:prstGeom>
-        </p:spPr>
-        <p:txBody>
-          <a:bodyPr vert="horz" lIns="91440" tIns="45720" rIns="91440" bIns="45720" rtlCol="0" anchor="b"/>
-          <a:lstStyle>
-            <a:lvl1pPr algn="r">
-              <a:defRPr sz="1200"/>
-            </a:lvl1pPr>
-          </a:lstStyle>
-          <a:p>
-            <a:fld id="{BB5E49A5-4136-284D-997B-48E1D791AD67}" type="slidenum">
-              <a:rPr lang="en-US" smtClean="0"/>
-              <a:t>‹#›</a:t>
-            </a:fld>
-            <a:endParaRPr lang="en-US"/>
-          </a:p>
-        </p:txBody>
-      </p:sp>
     </p:spTree>
     <p:extLst>
       <p:ext uri="{BB962C8B-B14F-4D97-AF65-F5344CB8AC3E}">
-        <p14:creationId xmlns:p14="http://schemas.microsoft.com/office/powerpoint/2010/main" val="2623252185"/>
+        <p14:creationId xmlns:p14="http://schemas.microsoft.com/office/powerpoint/2010/main" val="3127805593"/>
       </p:ext>
     </p:extLst>
   </p:cSld>
   <p:clrMap bg1="lt1" tx1="dk1" bg2="lt2" tx2="dk2" accent1="accent1" accent2="accent2" accent3="accent3" accent4="accent4" accent5="accent5" accent6="accent6" hlink="hlink" folHlink="folHlink"/>
   <p:notesStyle>
-    <a:lvl1pPr marL="0" algn="l" defTabSz="457200" rtl="0" eaLnBrk="1" latinLnBrk="0" hangingPunct="1">
+    <a:lvl1pPr marL="0" algn="l" defTabSz="914400" rtl="0" eaLnBrk="1" latinLnBrk="0" hangingPunct="1">
       <a:defRPr sz="1200" kern="1200">
         <a:solidFill>
           <a:schemeClr val="tx1"/>
@@ -384,7 +178,7 @@
         <a:cs typeface="+mn-cs"/>
       </a:defRPr>
     </a:lvl1pPr>
-    <a:lvl2pPr marL="457200" algn="l" defTabSz="457200" rtl="0" eaLnBrk="1" latinLnBrk="0" hangingPunct="1">
+    <a:lvl2pPr marL="457200" algn="l" defTabSz="914400" rtl="0" eaLnBrk="1" latinLnBrk="0" hangingPunct="1">
       <a:defRPr sz="1200" kern="1200">
         <a:solidFill>
           <a:schemeClr val="tx1"/>
@@ -394,7 +188,7 @@
         <a:cs typeface="+mn-cs"/>
       </a:defRPr>
     </a:lvl2pPr>
-    <a:lvl3pPr marL="914400" algn="l" defTabSz="457200" rtl="0" eaLnBrk="1" latinLnBrk="0" hangingPunct="1">
+    <a:lvl3pPr marL="914400" algn="l" defTabSz="914400" rtl="0" eaLnBrk="1" latinLnBrk="0" hangingPunct="1">
       <a:defRPr sz="1200" kern="1200">
         <a:solidFill>
           <a:schemeClr val="tx1"/>
@@ -404,7 +198,7 @@
         <a:cs typeface="+mn-cs"/>
       </a:defRPr>
     </a:lvl3pPr>
-    <a:lvl4pPr marL="1371600" algn="l" defTabSz="457200" rtl="0" eaLnBrk="1" latinLnBrk="0" hangingPunct="1">
+    <a:lvl4pPr marL="1371600" algn="l" defTabSz="914400" rtl="0" eaLnBrk="1" latinLnBrk="0" hangingPunct="1">
       <a:defRPr sz="1200" kern="1200">
         <a:solidFill>
           <a:schemeClr val="tx1"/>
@@ -414,7 +208,7 @@
         <a:cs typeface="+mn-cs"/>
       </a:defRPr>
     </a:lvl4pPr>
-    <a:lvl5pPr marL="1828800" algn="l" defTabSz="457200" rtl="0" eaLnBrk="1" latinLnBrk="0" hangingPunct="1">
+    <a:lvl5pPr marL="1828800" algn="l" defTabSz="914400" rtl="0" eaLnBrk="1" latinLnBrk="0" hangingPunct="1">
       <a:defRPr sz="1200" kern="1200">
         <a:solidFill>
           <a:schemeClr val="tx1"/>
@@ -424,7 +218,7 @@
         <a:cs typeface="+mn-cs"/>
       </a:defRPr>
     </a:lvl5pPr>
-    <a:lvl6pPr marL="2286000" algn="l" defTabSz="457200" rtl="0" eaLnBrk="1" latinLnBrk="0" hangingPunct="1">
+    <a:lvl6pPr marL="2286000" algn="l" defTabSz="914400" rtl="0" eaLnBrk="1" latinLnBrk="0" hangingPunct="1">
       <a:defRPr sz="1200" kern="1200">
         <a:solidFill>
           <a:schemeClr val="tx1"/>
@@ -434,7 +228,7 @@
         <a:cs typeface="+mn-cs"/>
       </a:defRPr>
     </a:lvl6pPr>
-    <a:lvl7pPr marL="2743200" algn="l" defTabSz="457200" rtl="0" eaLnBrk="1" latinLnBrk="0" hangingPunct="1">
+    <a:lvl7pPr marL="2743200" algn="l" defTabSz="914400" rtl="0" eaLnBrk="1" latinLnBrk="0" hangingPunct="1">
       <a:defRPr sz="1200" kern="1200">
         <a:solidFill>
           <a:schemeClr val="tx1"/>
@@ -444,7 +238,7 @@
         <a:cs typeface="+mn-cs"/>
       </a:defRPr>
     </a:lvl7pPr>
-    <a:lvl8pPr marL="3200400" algn="l" defTabSz="457200" rtl="0" eaLnBrk="1" latinLnBrk="0" hangingPunct="1">
+    <a:lvl8pPr marL="3200400" algn="l" defTabSz="914400" rtl="0" eaLnBrk="1" latinLnBrk="0" hangingPunct="1">
       <a:defRPr sz="1200" kern="1200">
         <a:solidFill>
           <a:schemeClr val="tx1"/>
@@ -454,7 +248,7 @@
         <a:cs typeface="+mn-cs"/>
       </a:defRPr>
     </a:lvl8pPr>
-    <a:lvl9pPr marL="3657600" algn="l" defTabSz="457200" rtl="0" eaLnBrk="1" latinLnBrk="0" hangingPunct="1">
+    <a:lvl9pPr marL="3657600" algn="l" defTabSz="914400" rtl="0" eaLnBrk="1" latinLnBrk="0" hangingPunct="1">
       <a:defRPr sz="1200" kern="1200">
         <a:solidFill>
           <a:schemeClr val="tx1"/>
@@ -469,7 +263,7 @@
 </file>
 
 <file path=ppt/notesSlides/notesSlide1.xml><?xml version="1.0" encoding="utf-8"?>
-<p:notes xmlns:a="http://schemas.openxmlformats.org/drawingml/2006/main" xmlns:p="http://schemas.openxmlformats.org/presentationml/2006/main" xmlns:r="http://schemas.openxmlformats.org/officeDocument/2006/relationships">
+<p:notes xmlns:a="http://schemas.openxmlformats.org/drawingml/2006/main" xmlns:r="http://schemas.openxmlformats.org/officeDocument/2006/relationships" xmlns:p="http://schemas.openxmlformats.org/presentationml/2006/main">
   <p:cSld>
     <p:spTree>
       <p:nvGrpSpPr>
@@ -489,7 +283,7 @@
         <p:nvSpPr>
           <p:cNvPr id="2" name="Slide Image Placeholder 1"/>
           <p:cNvSpPr>
-            <a:spLocks noGrp="1"/>
+            <a:spLocks noGrp="1" noRot="1" noChangeAspect="1"/>
           </p:cNvSpPr>
           <p:nvPr>
             <p:ph type="sldImg" idx="2"/>
@@ -504,7 +298,7 @@
             <a:spLocks noGrp="1"/>
           </p:cNvSpPr>
           <p:nvPr>
-            <p:ph type="body" idx="3" sz="quarter"/>
+            <p:ph type="body" sz="quarter" idx="3"/>
           </p:nvPr>
         </p:nvSpPr>
         <p:spPr/>
@@ -530,7 +324,7 @@
             <a:spLocks noGrp="1"/>
           </p:cNvSpPr>
           <p:nvPr>
-            <p:ph type="sldNum" idx="5" sz="quarter"/>
+            <p:ph type="sldNum" sz="quarter" idx="5"/>
           </p:nvPr>
         </p:nvSpPr>
         <p:spPr/>
@@ -544,7 +338,7 @@
 </file>
 
 <file path=ppt/notesSlides/notesSlide10.xml><?xml version="1.0" encoding="utf-8"?>
-<p:notes xmlns:a="http://schemas.openxmlformats.org/drawingml/2006/main" xmlns:p="http://schemas.openxmlformats.org/presentationml/2006/main" xmlns:r="http://schemas.openxmlformats.org/officeDocument/2006/relationships">
+<p:notes xmlns:a="http://schemas.openxmlformats.org/drawingml/2006/main" xmlns:r="http://schemas.openxmlformats.org/officeDocument/2006/relationships" xmlns:p="http://schemas.openxmlformats.org/presentationml/2006/main">
   <p:cSld>
     <p:spTree>
       <p:nvGrpSpPr>
@@ -564,7 +358,7 @@
         <p:nvSpPr>
           <p:cNvPr id="2" name="Slide Image Placeholder 1"/>
           <p:cNvSpPr>
-            <a:spLocks noGrp="1"/>
+            <a:spLocks noGrp="1" noRot="1" noChangeAspect="1"/>
           </p:cNvSpPr>
           <p:nvPr>
             <p:ph type="sldImg" idx="2"/>
@@ -579,7 +373,7 @@
             <a:spLocks noGrp="1"/>
           </p:cNvSpPr>
           <p:nvPr>
-            <p:ph type="body" idx="3" sz="quarter"/>
+            <p:ph type="body" sz="quarter" idx="3"/>
           </p:nvPr>
         </p:nvSpPr>
         <p:spPr/>
@@ -605,7 +399,7 @@
             <a:spLocks noGrp="1"/>
           </p:cNvSpPr>
           <p:nvPr>
-            <p:ph type="sldNum" idx="5" sz="quarter"/>
+            <p:ph type="sldNum" sz="quarter" idx="5"/>
           </p:nvPr>
         </p:nvSpPr>
         <p:spPr/>
@@ -619,7 +413,7 @@
 </file>
 
 <file path=ppt/notesSlides/notesSlide11.xml><?xml version="1.0" encoding="utf-8"?>
-<p:notes xmlns:a="http://schemas.openxmlformats.org/drawingml/2006/main" xmlns:p="http://schemas.openxmlformats.org/presentationml/2006/main" xmlns:r="http://schemas.openxmlformats.org/officeDocument/2006/relationships">
+<p:notes xmlns:a="http://schemas.openxmlformats.org/drawingml/2006/main" xmlns:r="http://schemas.openxmlformats.org/officeDocument/2006/relationships" xmlns:p="http://schemas.openxmlformats.org/presentationml/2006/main">
   <p:cSld>
     <p:spTree>
       <p:nvGrpSpPr>
@@ -639,7 +433,7 @@
         <p:nvSpPr>
           <p:cNvPr id="2" name="Slide Image Placeholder 1"/>
           <p:cNvSpPr>
-            <a:spLocks noGrp="1"/>
+            <a:spLocks noGrp="1" noRot="1" noChangeAspect="1"/>
           </p:cNvSpPr>
           <p:nvPr>
             <p:ph type="sldImg" idx="2"/>
@@ -654,7 +448,7 @@
             <a:spLocks noGrp="1"/>
           </p:cNvSpPr>
           <p:nvPr>
-            <p:ph type="body" idx="3" sz="quarter"/>
+            <p:ph type="body" sz="quarter" idx="3"/>
           </p:nvPr>
         </p:nvSpPr>
         <p:spPr/>
@@ -680,7 +474,7 @@
             <a:spLocks noGrp="1"/>
           </p:cNvSpPr>
           <p:nvPr>
-            <p:ph type="sldNum" idx="5" sz="quarter"/>
+            <p:ph type="sldNum" sz="quarter" idx="5"/>
           </p:nvPr>
         </p:nvSpPr>
         <p:spPr/>
@@ -694,7 +488,7 @@
 </file>
 
 <file path=ppt/notesSlides/notesSlide12.xml><?xml version="1.0" encoding="utf-8"?>
-<p:notes xmlns:a="http://schemas.openxmlformats.org/drawingml/2006/main" xmlns:p="http://schemas.openxmlformats.org/presentationml/2006/main" xmlns:r="http://schemas.openxmlformats.org/officeDocument/2006/relationships">
+<p:notes xmlns:a="http://schemas.openxmlformats.org/drawingml/2006/main" xmlns:r="http://schemas.openxmlformats.org/officeDocument/2006/relationships" xmlns:p="http://schemas.openxmlformats.org/presentationml/2006/main">
   <p:cSld>
     <p:spTree>
       <p:nvGrpSpPr>
@@ -714,7 +508,7 @@
         <p:nvSpPr>
           <p:cNvPr id="2" name="Slide Image Placeholder 1"/>
           <p:cNvSpPr>
-            <a:spLocks noGrp="1"/>
+            <a:spLocks noGrp="1" noRot="1" noChangeAspect="1"/>
           </p:cNvSpPr>
           <p:nvPr>
             <p:ph type="sldImg" idx="2"/>
@@ -729,7 +523,7 @@
             <a:spLocks noGrp="1"/>
           </p:cNvSpPr>
           <p:nvPr>
-            <p:ph type="body" idx="3" sz="quarter"/>
+            <p:ph type="body" sz="quarter" idx="3"/>
           </p:nvPr>
         </p:nvSpPr>
         <p:spPr/>
@@ -755,7 +549,7 @@
             <a:spLocks noGrp="1"/>
           </p:cNvSpPr>
           <p:nvPr>
-            <p:ph type="sldNum" idx="5" sz="quarter"/>
+            <p:ph type="sldNum" sz="quarter" idx="5"/>
           </p:nvPr>
         </p:nvSpPr>
         <p:spPr/>
@@ -769,7 +563,7 @@
 </file>
 
 <file path=ppt/notesSlides/notesSlide2.xml><?xml version="1.0" encoding="utf-8"?>
-<p:notes xmlns:a="http://schemas.openxmlformats.org/drawingml/2006/main" xmlns:p="http://schemas.openxmlformats.org/presentationml/2006/main" xmlns:r="http://schemas.openxmlformats.org/officeDocument/2006/relationships">
+<p:notes xmlns:a="http://schemas.openxmlformats.org/drawingml/2006/main" xmlns:r="http://schemas.openxmlformats.org/officeDocument/2006/relationships" xmlns:p="http://schemas.openxmlformats.org/presentationml/2006/main">
   <p:cSld>
     <p:spTree>
       <p:nvGrpSpPr>
@@ -789,7 +583,7 @@
         <p:nvSpPr>
           <p:cNvPr id="2" name="Slide Image Placeholder 1"/>
           <p:cNvSpPr>
-            <a:spLocks noGrp="1"/>
+            <a:spLocks noGrp="1" noRot="1" noChangeAspect="1"/>
           </p:cNvSpPr>
           <p:nvPr>
             <p:ph type="sldImg" idx="2"/>
@@ -804,7 +598,7 @@
             <a:spLocks noGrp="1"/>
           </p:cNvSpPr>
           <p:nvPr>
-            <p:ph type="body" idx="3" sz="quarter"/>
+            <p:ph type="body" sz="quarter" idx="3"/>
           </p:nvPr>
         </p:nvSpPr>
         <p:spPr/>
@@ -830,7 +624,7 @@
             <a:spLocks noGrp="1"/>
           </p:cNvSpPr>
           <p:nvPr>
-            <p:ph type="sldNum" idx="5" sz="quarter"/>
+            <p:ph type="sldNum" sz="quarter" idx="5"/>
           </p:nvPr>
         </p:nvSpPr>
         <p:spPr/>
@@ -844,7 +638,7 @@
 </file>
 
 <file path=ppt/notesSlides/notesSlide3.xml><?xml version="1.0" encoding="utf-8"?>
-<p:notes xmlns:a="http://schemas.openxmlformats.org/drawingml/2006/main" xmlns:p="http://schemas.openxmlformats.org/presentationml/2006/main" xmlns:r="http://schemas.openxmlformats.org/officeDocument/2006/relationships">
+<p:notes xmlns:a="http://schemas.openxmlformats.org/drawingml/2006/main" xmlns:r="http://schemas.openxmlformats.org/officeDocument/2006/relationships" xmlns:p="http://schemas.openxmlformats.org/presentationml/2006/main">
   <p:cSld>
     <p:spTree>
       <p:nvGrpSpPr>
@@ -864,7 +658,7 @@
         <p:nvSpPr>
           <p:cNvPr id="2" name="Slide Image Placeholder 1"/>
           <p:cNvSpPr>
-            <a:spLocks noGrp="1"/>
+            <a:spLocks noGrp="1" noRot="1" noChangeAspect="1"/>
           </p:cNvSpPr>
           <p:nvPr>
             <p:ph type="sldImg" idx="2"/>
@@ -879,7 +673,7 @@
             <a:spLocks noGrp="1"/>
           </p:cNvSpPr>
           <p:nvPr>
-            <p:ph type="body" idx="3" sz="quarter"/>
+            <p:ph type="body" sz="quarter" idx="3"/>
           </p:nvPr>
         </p:nvSpPr>
         <p:spPr/>
@@ -905,7 +699,7 @@
             <a:spLocks noGrp="1"/>
           </p:cNvSpPr>
           <p:nvPr>
-            <p:ph type="sldNum" idx="5" sz="quarter"/>
+            <p:ph type="sldNum" sz="quarter" idx="5"/>
           </p:nvPr>
         </p:nvSpPr>
         <p:spPr/>
@@ -919,7 +713,7 @@
 </file>
 
 <file path=ppt/notesSlides/notesSlide4.xml><?xml version="1.0" encoding="utf-8"?>
-<p:notes xmlns:a="http://schemas.openxmlformats.org/drawingml/2006/main" xmlns:p="http://schemas.openxmlformats.org/presentationml/2006/main" xmlns:r="http://schemas.openxmlformats.org/officeDocument/2006/relationships">
+<p:notes xmlns:a="http://schemas.openxmlformats.org/drawingml/2006/main" xmlns:r="http://schemas.openxmlformats.org/officeDocument/2006/relationships" xmlns:p="http://schemas.openxmlformats.org/presentationml/2006/main">
   <p:cSld>
     <p:spTree>
       <p:nvGrpSpPr>
@@ -939,7 +733,7 @@
         <p:nvSpPr>
           <p:cNvPr id="2" name="Slide Image Placeholder 1"/>
           <p:cNvSpPr>
-            <a:spLocks noGrp="1"/>
+            <a:spLocks noGrp="1" noRot="1" noChangeAspect="1"/>
           </p:cNvSpPr>
           <p:nvPr>
             <p:ph type="sldImg" idx="2"/>
@@ -954,7 +748,7 @@
             <a:spLocks noGrp="1"/>
           </p:cNvSpPr>
           <p:nvPr>
-            <p:ph type="body" idx="3" sz="quarter"/>
+            <p:ph type="body" sz="quarter" idx="3"/>
           </p:nvPr>
         </p:nvSpPr>
         <p:spPr/>
@@ -980,7 +774,7 @@
             <a:spLocks noGrp="1"/>
           </p:cNvSpPr>
           <p:nvPr>
-            <p:ph type="sldNum" idx="5" sz="quarter"/>
+            <p:ph type="sldNum" sz="quarter" idx="5"/>
           </p:nvPr>
         </p:nvSpPr>
         <p:spPr/>
@@ -994,7 +788,7 @@
 </file>
 
 <file path=ppt/notesSlides/notesSlide5.xml><?xml version="1.0" encoding="utf-8"?>
-<p:notes xmlns:a="http://schemas.openxmlformats.org/drawingml/2006/main" xmlns:p="http://schemas.openxmlformats.org/presentationml/2006/main" xmlns:r="http://schemas.openxmlformats.org/officeDocument/2006/relationships">
+<p:notes xmlns:a="http://schemas.openxmlformats.org/drawingml/2006/main" xmlns:r="http://schemas.openxmlformats.org/officeDocument/2006/relationships" xmlns:p="http://schemas.openxmlformats.org/presentationml/2006/main">
   <p:cSld>
     <p:spTree>
       <p:nvGrpSpPr>
@@ -1014,7 +808,7 @@
         <p:nvSpPr>
           <p:cNvPr id="2" name="Slide Image Placeholder 1"/>
           <p:cNvSpPr>
-            <a:spLocks noGrp="1"/>
+            <a:spLocks noGrp="1" noRot="1" noChangeAspect="1"/>
           </p:cNvSpPr>
           <p:nvPr>
             <p:ph type="sldImg" idx="2"/>
@@ -1029,7 +823,7 @@
             <a:spLocks noGrp="1"/>
           </p:cNvSpPr>
           <p:nvPr>
-            <p:ph type="body" idx="3" sz="quarter"/>
+            <p:ph type="body" sz="quarter" idx="3"/>
           </p:nvPr>
         </p:nvSpPr>
         <p:spPr/>
@@ -1055,7 +849,7 @@
             <a:spLocks noGrp="1"/>
           </p:cNvSpPr>
           <p:nvPr>
-            <p:ph type="sldNum" idx="5" sz="quarter"/>
+            <p:ph type="sldNum" sz="quarter" idx="5"/>
           </p:nvPr>
         </p:nvSpPr>
         <p:spPr/>
@@ -1069,7 +863,7 @@
 </file>
 
 <file path=ppt/notesSlides/notesSlide6.xml><?xml version="1.0" encoding="utf-8"?>
-<p:notes xmlns:a="http://schemas.openxmlformats.org/drawingml/2006/main" xmlns:p="http://schemas.openxmlformats.org/presentationml/2006/main" xmlns:r="http://schemas.openxmlformats.org/officeDocument/2006/relationships">
+<p:notes xmlns:a="http://schemas.openxmlformats.org/drawingml/2006/main" xmlns:r="http://schemas.openxmlformats.org/officeDocument/2006/relationships" xmlns:p="http://schemas.openxmlformats.org/presentationml/2006/main">
   <p:cSld>
     <p:spTree>
       <p:nvGrpSpPr>
@@ -1089,7 +883,7 @@
         <p:nvSpPr>
           <p:cNvPr id="2" name="Slide Image Placeholder 1"/>
           <p:cNvSpPr>
-            <a:spLocks noGrp="1"/>
+            <a:spLocks noGrp="1" noRot="1" noChangeAspect="1"/>
           </p:cNvSpPr>
           <p:nvPr>
             <p:ph type="sldImg" idx="2"/>
@@ -1104,7 +898,7 @@
             <a:spLocks noGrp="1"/>
           </p:cNvSpPr>
           <p:nvPr>
-            <p:ph type="body" idx="3" sz="quarter"/>
+            <p:ph type="body" sz="quarter" idx="3"/>
           </p:nvPr>
         </p:nvSpPr>
         <p:spPr/>
@@ -1130,7 +924,7 @@
             <a:spLocks noGrp="1"/>
           </p:cNvSpPr>
           <p:nvPr>
-            <p:ph type="sldNum" idx="5" sz="quarter"/>
+            <p:ph type="sldNum" sz="quarter" idx="5"/>
           </p:nvPr>
         </p:nvSpPr>
         <p:spPr/>
@@ -1144,7 +938,7 @@
 </file>
 
 <file path=ppt/notesSlides/notesSlide7.xml><?xml version="1.0" encoding="utf-8"?>
-<p:notes xmlns:a="http://schemas.openxmlformats.org/drawingml/2006/main" xmlns:p="http://schemas.openxmlformats.org/presentationml/2006/main" xmlns:r="http://schemas.openxmlformats.org/officeDocument/2006/relationships">
+<p:notes xmlns:a="http://schemas.openxmlformats.org/drawingml/2006/main" xmlns:r="http://schemas.openxmlformats.org/officeDocument/2006/relationships" xmlns:p="http://schemas.openxmlformats.org/presentationml/2006/main">
   <p:cSld>
     <p:spTree>
       <p:nvGrpSpPr>
@@ -1164,7 +958,7 @@
         <p:nvSpPr>
           <p:cNvPr id="2" name="Slide Image Placeholder 1"/>
           <p:cNvSpPr>
-            <a:spLocks noGrp="1"/>
+            <a:spLocks noGrp="1" noRot="1" noChangeAspect="1"/>
           </p:cNvSpPr>
           <p:nvPr>
             <p:ph type="sldImg" idx="2"/>
@@ -1179,7 +973,7 @@
             <a:spLocks noGrp="1"/>
           </p:cNvSpPr>
           <p:nvPr>
-            <p:ph type="body" idx="3" sz="quarter"/>
+            <p:ph type="body" sz="quarter" idx="3"/>
           </p:nvPr>
         </p:nvSpPr>
         <p:spPr/>
@@ -1205,7 +999,7 @@
             <a:spLocks noGrp="1"/>
           </p:cNvSpPr>
           <p:nvPr>
-            <p:ph type="sldNum" idx="5" sz="quarter"/>
+            <p:ph type="sldNum" sz="quarter" idx="5"/>
           </p:nvPr>
         </p:nvSpPr>
         <p:spPr/>
@@ -1219,7 +1013,7 @@
 </file>
 
 <file path=ppt/notesSlides/notesSlide8.xml><?xml version="1.0" encoding="utf-8"?>
-<p:notes xmlns:a="http://schemas.openxmlformats.org/drawingml/2006/main" xmlns:p="http://schemas.openxmlformats.org/presentationml/2006/main" xmlns:r="http://schemas.openxmlformats.org/officeDocument/2006/relationships">
+<p:notes xmlns:a="http://schemas.openxmlformats.org/drawingml/2006/main" xmlns:r="http://schemas.openxmlformats.org/officeDocument/2006/relationships" xmlns:p="http://schemas.openxmlformats.org/presentationml/2006/main">
   <p:cSld>
     <p:spTree>
       <p:nvGrpSpPr>
@@ -1239,7 +1033,7 @@
         <p:nvSpPr>
           <p:cNvPr id="2" name="Slide Image Placeholder 1"/>
           <p:cNvSpPr>
-            <a:spLocks noGrp="1"/>
+            <a:spLocks noGrp="1" noRot="1" noChangeAspect="1"/>
           </p:cNvSpPr>
           <p:nvPr>
             <p:ph type="sldImg" idx="2"/>
@@ -1254,7 +1048,7 @@
             <a:spLocks noGrp="1"/>
           </p:cNvSpPr>
           <p:nvPr>
-            <p:ph type="body" idx="3" sz="quarter"/>
+            <p:ph type="body" sz="quarter" idx="3"/>
           </p:nvPr>
         </p:nvSpPr>
         <p:spPr/>
@@ -1280,7 +1074,7 @@
             <a:spLocks noGrp="1"/>
           </p:cNvSpPr>
           <p:nvPr>
-            <p:ph type="sldNum" idx="5" sz="quarter"/>
+            <p:ph type="sldNum" sz="quarter" idx="5"/>
           </p:nvPr>
         </p:nvSpPr>
         <p:spPr/>
@@ -1294,7 +1088,7 @@
 </file>
 
 <file path=ppt/notesSlides/notesSlide9.xml><?xml version="1.0" encoding="utf-8"?>
-<p:notes xmlns:a="http://schemas.openxmlformats.org/drawingml/2006/main" xmlns:p="http://schemas.openxmlformats.org/presentationml/2006/main" xmlns:r="http://schemas.openxmlformats.org/officeDocument/2006/relationships">
+<p:notes xmlns:a="http://schemas.openxmlformats.org/drawingml/2006/main" xmlns:r="http://schemas.openxmlformats.org/officeDocument/2006/relationships" xmlns:p="http://schemas.openxmlformats.org/presentationml/2006/main">
   <p:cSld>
     <p:spTree>
       <p:nvGrpSpPr>
@@ -1314,7 +1108,7 @@
         <p:nvSpPr>
           <p:cNvPr id="2" name="Slide Image Placeholder 1"/>
           <p:cNvSpPr>
-            <a:spLocks noGrp="1"/>
+            <a:spLocks noGrp="1" noRot="1" noChangeAspect="1"/>
           </p:cNvSpPr>
           <p:nvPr>
             <p:ph type="sldImg" idx="2"/>
@@ -1329,7 +1123,7 @@
             <a:spLocks noGrp="1"/>
           </p:cNvSpPr>
           <p:nvPr>
-            <p:ph type="body" idx="3" sz="quarter"/>
+            <p:ph type="body" sz="quarter" idx="3"/>
           </p:nvPr>
         </p:nvSpPr>
         <p:spPr/>
@@ -1355,7 +1149,7 @@
             <a:spLocks noGrp="1"/>
           </p:cNvSpPr>
           <p:nvPr>
-            <p:ph type="sldNum" idx="5" sz="quarter"/>
+            <p:ph type="sldNum" sz="quarter" idx="5"/>
           </p:nvPr>
         </p:nvSpPr>
         <p:spPr/>
@@ -1406,10 +1200,9 @@
           <a:lstStyle/>
           <a:p>
             <a:r>
-              <a:rPr lang="en-US" smtClean="0"/>
+              <a:rPr lang="en-US"/>
               <a:t>Click to edit Master title style</a:t>
             </a:r>
-            <a:endParaRPr lang="en-US"/>
           </a:p>
         </p:txBody>
       </p:sp>
@@ -1525,10 +1318,9 @@
           </a:lstStyle>
           <a:p>
             <a:r>
-              <a:rPr lang="en-US" smtClean="0"/>
+              <a:rPr lang="en-US"/>
               <a:t>Click to edit Master subtitle style</a:t>
             </a:r>
-            <a:endParaRPr lang="en-US"/>
           </a:p>
         </p:txBody>
       </p:sp>
@@ -1549,7 +1341,7 @@
           <a:p>
             <a:fld id="{5BCAD085-E8A6-8845-BD4E-CB4CCA059FC4}" type="datetimeFigureOut">
               <a:rPr lang="en-US" smtClean="0"/>
-              <a:t>1/27/13</a:t>
+              <a:t>10/24/2026</a:t>
             </a:fld>
             <a:endParaRPr lang="en-US"/>
           </a:p>
@@ -1643,10 +1435,9 @@
           <a:lstStyle/>
           <a:p>
             <a:r>
-              <a:rPr lang="en-US" smtClean="0"/>
+              <a:rPr lang="en-US"/>
               <a:t>Click to edit Master title style</a:t>
             </a:r>
-            <a:endParaRPr lang="en-US"/>
           </a:p>
         </p:txBody>
       </p:sp>
@@ -1667,38 +1458,37 @@
           <a:p>
             <a:pPr lvl="0"/>
             <a:r>
-              <a:rPr lang="en-US" smtClean="0"/>
+              <a:rPr lang="en-US"/>
               <a:t>Click to edit Master text styles</a:t>
             </a:r>
           </a:p>
           <a:p>
             <a:pPr lvl="1"/>
             <a:r>
-              <a:rPr lang="en-US" smtClean="0"/>
+              <a:rPr lang="en-US"/>
               <a:t>Second level</a:t>
             </a:r>
           </a:p>
           <a:p>
             <a:pPr lvl="2"/>
             <a:r>
-              <a:rPr lang="en-US" smtClean="0"/>
+              <a:rPr lang="en-US"/>
               <a:t>Third level</a:t>
             </a:r>
           </a:p>
           <a:p>
             <a:pPr lvl="3"/>
             <a:r>
-              <a:rPr lang="en-US" smtClean="0"/>
+              <a:rPr lang="en-US"/>
               <a:t>Fourth level</a:t>
             </a:r>
           </a:p>
           <a:p>
             <a:pPr lvl="4"/>
             <a:r>
-              <a:rPr lang="en-US" smtClean="0"/>
+              <a:rPr lang="en-US"/>
               <a:t>Fifth level</a:t>
             </a:r>
-            <a:endParaRPr lang="en-US"/>
           </a:p>
         </p:txBody>
       </p:sp>
@@ -1719,7 +1509,7 @@
           <a:p>
             <a:fld id="{5BCAD085-E8A6-8845-BD4E-CB4CCA059FC4}" type="datetimeFigureOut">
               <a:rPr lang="en-US" smtClean="0"/>
-              <a:t>1/27/13</a:t>
+              <a:t>10/24/2026</a:t>
             </a:fld>
             <a:endParaRPr lang="en-US"/>
           </a:p>
@@ -1818,10 +1608,9 @@
           <a:lstStyle/>
           <a:p>
             <a:r>
-              <a:rPr lang="en-US" smtClean="0"/>
+              <a:rPr lang="en-US"/>
               <a:t>Click to edit Master title style</a:t>
             </a:r>
-            <a:endParaRPr lang="en-US"/>
           </a:p>
         </p:txBody>
       </p:sp>
@@ -1847,38 +1636,37 @@
           <a:p>
             <a:pPr lvl="0"/>
             <a:r>
-              <a:rPr lang="en-US" smtClean="0"/>
+              <a:rPr lang="en-US"/>
               <a:t>Click to edit Master text styles</a:t>
             </a:r>
           </a:p>
           <a:p>
             <a:pPr lvl="1"/>
             <a:r>
-              <a:rPr lang="en-US" smtClean="0"/>
+              <a:rPr lang="en-US"/>
               <a:t>Second level</a:t>
             </a:r>
           </a:p>
           <a:p>
             <a:pPr lvl="2"/>
             <a:r>
-              <a:rPr lang="en-US" smtClean="0"/>
+              <a:rPr lang="en-US"/>
               <a:t>Third level</a:t>
             </a:r>
           </a:p>
           <a:p>
             <a:pPr lvl="3"/>
             <a:r>
-              <a:rPr lang="en-US" smtClean="0"/>
+              <a:rPr lang="en-US"/>
               <a:t>Fourth level</a:t>
             </a:r>
           </a:p>
           <a:p>
             <a:pPr lvl="4"/>
             <a:r>
-              <a:rPr lang="en-US" smtClean="0"/>
+              <a:rPr lang="en-US"/>
               <a:t>Fifth level</a:t>
             </a:r>
-            <a:endParaRPr lang="en-US"/>
           </a:p>
         </p:txBody>
       </p:sp>
@@ -1899,7 +1687,7 @@
           <a:p>
             <a:fld id="{5BCAD085-E8A6-8845-BD4E-CB4CCA059FC4}" type="datetimeFigureOut">
               <a:rPr lang="en-US" smtClean="0"/>
-              <a:t>1/27/13</a:t>
+              <a:t>10/24/2026</a:t>
             </a:fld>
             <a:endParaRPr lang="en-US"/>
           </a:p>
@@ -1993,10 +1781,9 @@
           <a:lstStyle/>
           <a:p>
             <a:r>
-              <a:rPr lang="en-US" smtClean="0"/>
+              <a:rPr lang="en-US"/>
               <a:t>Click to edit Master title style</a:t>
             </a:r>
-            <a:endParaRPr lang="en-US"/>
           </a:p>
         </p:txBody>
       </p:sp>
@@ -2017,38 +1804,37 @@
           <a:p>
             <a:pPr lvl="0"/>
             <a:r>
-              <a:rPr lang="en-US" smtClean="0"/>
+              <a:rPr lang="en-US"/>
               <a:t>Click to edit Master text styles</a:t>
             </a:r>
           </a:p>
           <a:p>
             <a:pPr lvl="1"/>
             <a:r>
-              <a:rPr lang="en-US" smtClean="0"/>
+              <a:rPr lang="en-US"/>
               <a:t>Second level</a:t>
             </a:r>
           </a:p>
           <a:p>
             <a:pPr lvl="2"/>
             <a:r>
-              <a:rPr lang="en-US" smtClean="0"/>
+              <a:rPr lang="en-US"/>
               <a:t>Third level</a:t>
             </a:r>
           </a:p>
           <a:p>
             <a:pPr lvl="3"/>
             <a:r>
-              <a:rPr lang="en-US" smtClean="0"/>
+              <a:rPr lang="en-US"/>
               <a:t>Fourth level</a:t>
             </a:r>
           </a:p>
           <a:p>
             <a:pPr lvl="4"/>
             <a:r>
-              <a:rPr lang="en-US" smtClean="0"/>
+              <a:rPr lang="en-US"/>
               <a:t>Fifth level</a:t>
             </a:r>
-            <a:endParaRPr lang="en-US"/>
           </a:p>
         </p:txBody>
       </p:sp>
@@ -2069,7 +1855,7 @@
           <a:p>
             <a:fld id="{5BCAD085-E8A6-8845-BD4E-CB4CCA059FC4}" type="datetimeFigureOut">
               <a:rPr lang="en-US" smtClean="0"/>
-              <a:t>1/27/13</a:t>
+              <a:t>10/24/2026</a:t>
             </a:fld>
             <a:endParaRPr lang="en-US"/>
           </a:p>
@@ -2172,10 +1958,9 @@
           </a:lstStyle>
           <a:p>
             <a:r>
-              <a:rPr lang="en-US" smtClean="0"/>
+              <a:rPr lang="en-US"/>
               <a:t>Click to edit Master title style</a:t>
             </a:r>
-            <a:endParaRPr lang="en-US"/>
           </a:p>
         </p:txBody>
       </p:sp>
@@ -2292,7 +2077,7 @@
           <a:p>
             <a:pPr lvl="0"/>
             <a:r>
-              <a:rPr lang="en-US" smtClean="0"/>
+              <a:rPr lang="en-US"/>
               <a:t>Click to edit Master text styles</a:t>
             </a:r>
           </a:p>
@@ -2315,7 +2100,7 @@
           <a:p>
             <a:fld id="{5BCAD085-E8A6-8845-BD4E-CB4CCA059FC4}" type="datetimeFigureOut">
               <a:rPr lang="en-US" smtClean="0"/>
-              <a:t>1/27/13</a:t>
+              <a:t>10/24/2026</a:t>
             </a:fld>
             <a:endParaRPr lang="en-US"/>
           </a:p>
@@ -2409,10 +2194,9 @@
           <a:lstStyle/>
           <a:p>
             <a:r>
-              <a:rPr lang="en-US" smtClean="0"/>
+              <a:rPr lang="en-US"/>
               <a:t>Click to edit Master title style</a:t>
             </a:r>
-            <a:endParaRPr lang="en-US"/>
           </a:p>
         </p:txBody>
       </p:sp>
@@ -2466,38 +2250,37 @@
           <a:p>
             <a:pPr lvl="0"/>
             <a:r>
-              <a:rPr lang="en-US" smtClean="0"/>
+              <a:rPr lang="en-US"/>
               <a:t>Click to edit Master text styles</a:t>
             </a:r>
           </a:p>
           <a:p>
             <a:pPr lvl="1"/>
             <a:r>
-              <a:rPr lang="en-US" smtClean="0"/>
+              <a:rPr lang="en-US"/>
               <a:t>Second level</a:t>
             </a:r>
           </a:p>
           <a:p>
             <a:pPr lvl="2"/>
             <a:r>
-              <a:rPr lang="en-US" smtClean="0"/>
+              <a:rPr lang="en-US"/>
               <a:t>Third level</a:t>
             </a:r>
           </a:p>
           <a:p>
             <a:pPr lvl="3"/>
             <a:r>
-              <a:rPr lang="en-US" smtClean="0"/>
+              <a:rPr lang="en-US"/>
               <a:t>Fourth level</a:t>
             </a:r>
           </a:p>
           <a:p>
             <a:pPr lvl="4"/>
             <a:r>
-              <a:rPr lang="en-US" smtClean="0"/>
+              <a:rPr lang="en-US"/>
               <a:t>Fifth level</a:t>
             </a:r>
-            <a:endParaRPr lang="en-US"/>
           </a:p>
         </p:txBody>
       </p:sp>
@@ -2551,38 +2334,37 @@
           <a:p>
             <a:pPr lvl="0"/>
             <a:r>
-              <a:rPr lang="en-US" smtClean="0"/>
+              <a:rPr lang="en-US"/>
               <a:t>Click to edit Master text styles</a:t>
             </a:r>
           </a:p>
           <a:p>
             <a:pPr lvl="1"/>
             <a:r>
-              <a:rPr lang="en-US" smtClean="0"/>
+              <a:rPr lang="en-US"/>
               <a:t>Second level</a:t>
             </a:r>
           </a:p>
           <a:p>
             <a:pPr lvl="2"/>
             <a:r>
-              <a:rPr lang="en-US" smtClean="0"/>
+              <a:rPr lang="en-US"/>
               <a:t>Third level</a:t>
             </a:r>
           </a:p>
           <a:p>
             <a:pPr lvl="3"/>
             <a:r>
-              <a:rPr lang="en-US" smtClean="0"/>
+              <a:rPr lang="en-US"/>
               <a:t>Fourth level</a:t>
             </a:r>
           </a:p>
           <a:p>
             <a:pPr lvl="4"/>
             <a:r>
-              <a:rPr lang="en-US" smtClean="0"/>
+              <a:rPr lang="en-US"/>
               <a:t>Fifth level</a:t>
             </a:r>
-            <a:endParaRPr lang="en-US"/>
           </a:p>
         </p:txBody>
       </p:sp>
@@ -2603,7 +2385,7 @@
           <a:p>
             <a:fld id="{5BCAD085-E8A6-8845-BD4E-CB4CCA059FC4}" type="datetimeFigureOut">
               <a:rPr lang="en-US" smtClean="0"/>
-              <a:t>1/27/13</a:t>
+              <a:t>10/24/2026</a:t>
             </a:fld>
             <a:endParaRPr lang="en-US"/>
           </a:p>
@@ -2701,10 +2483,9 @@
           </a:lstStyle>
           <a:p>
             <a:r>
-              <a:rPr lang="en-US" smtClean="0"/>
+              <a:rPr lang="en-US"/>
               <a:t>Click to edit Master title style</a:t>
             </a:r>
-            <a:endParaRPr lang="en-US"/>
           </a:p>
         </p:txBody>
       </p:sp>
@@ -2767,7 +2548,7 @@
           <a:p>
             <a:pPr lvl="0"/>
             <a:r>
-              <a:rPr lang="en-US" smtClean="0"/>
+              <a:rPr lang="en-US"/>
               <a:t>Click to edit Master text styles</a:t>
             </a:r>
           </a:p>
@@ -2823,38 +2604,37 @@
           <a:p>
             <a:pPr lvl="0"/>
             <a:r>
-              <a:rPr lang="en-US" smtClean="0"/>
+              <a:rPr lang="en-US"/>
               <a:t>Click to edit Master text styles</a:t>
             </a:r>
           </a:p>
           <a:p>
             <a:pPr lvl="1"/>
             <a:r>
-              <a:rPr lang="en-US" smtClean="0"/>
+              <a:rPr lang="en-US"/>
               <a:t>Second level</a:t>
             </a:r>
           </a:p>
           <a:p>
             <a:pPr lvl="2"/>
             <a:r>
-              <a:rPr lang="en-US" smtClean="0"/>
+              <a:rPr lang="en-US"/>
               <a:t>Third level</a:t>
             </a:r>
           </a:p>
           <a:p>
             <a:pPr lvl="3"/>
             <a:r>
-              <a:rPr lang="en-US" smtClean="0"/>
+              <a:rPr lang="en-US"/>
               <a:t>Fourth level</a:t>
             </a:r>
           </a:p>
           <a:p>
             <a:pPr lvl="4"/>
             <a:r>
-              <a:rPr lang="en-US" smtClean="0"/>
+              <a:rPr lang="en-US"/>
               <a:t>Fifth level</a:t>
             </a:r>
-            <a:endParaRPr lang="en-US"/>
           </a:p>
         </p:txBody>
       </p:sp>
@@ -2917,7 +2697,7 @@
           <a:p>
             <a:pPr lvl="0"/>
             <a:r>
-              <a:rPr lang="en-US" smtClean="0"/>
+              <a:rPr lang="en-US"/>
               <a:t>Click to edit Master text styles</a:t>
             </a:r>
           </a:p>
@@ -2973,38 +2753,37 @@
           <a:p>
             <a:pPr lvl="0"/>
             <a:r>
-              <a:rPr lang="en-US" smtClean="0"/>
+              <a:rPr lang="en-US"/>
               <a:t>Click to edit Master text styles</a:t>
             </a:r>
           </a:p>
           <a:p>
             <a:pPr lvl="1"/>
             <a:r>
-              <a:rPr lang="en-US" smtClean="0"/>
+              <a:rPr lang="en-US"/>
               <a:t>Second level</a:t>
             </a:r>
           </a:p>
           <a:p>
             <a:pPr lvl="2"/>
             <a:r>
-              <a:rPr lang="en-US" smtClean="0"/>
+              <a:rPr lang="en-US"/>
               <a:t>Third level</a:t>
             </a:r>
           </a:p>
           <a:p>
             <a:pPr lvl="3"/>
             <a:r>
-              <a:rPr lang="en-US" smtClean="0"/>
+              <a:rPr lang="en-US"/>
               <a:t>Fourth level</a:t>
             </a:r>
           </a:p>
           <a:p>
             <a:pPr lvl="4"/>
             <a:r>
-              <a:rPr lang="en-US" smtClean="0"/>
+              <a:rPr lang="en-US"/>
               <a:t>Fifth level</a:t>
             </a:r>
-            <a:endParaRPr lang="en-US"/>
           </a:p>
         </p:txBody>
       </p:sp>
@@ -3025,7 +2804,7 @@
           <a:p>
             <a:fld id="{5BCAD085-E8A6-8845-BD4E-CB4CCA059FC4}" type="datetimeFigureOut">
               <a:rPr lang="en-US" smtClean="0"/>
-              <a:t>1/27/13</a:t>
+              <a:t>10/24/2026</a:t>
             </a:fld>
             <a:endParaRPr lang="en-US"/>
           </a:p>
@@ -3119,10 +2898,9 @@
           <a:lstStyle/>
           <a:p>
             <a:r>
-              <a:rPr lang="en-US" smtClean="0"/>
+              <a:rPr lang="en-US"/>
               <a:t>Click to edit Master title style</a:t>
             </a:r>
-            <a:endParaRPr lang="en-US"/>
           </a:p>
         </p:txBody>
       </p:sp>
@@ -3143,7 +2921,7 @@
           <a:p>
             <a:fld id="{5BCAD085-E8A6-8845-BD4E-CB4CCA059FC4}" type="datetimeFigureOut">
               <a:rPr lang="en-US" smtClean="0"/>
-              <a:t>1/27/13</a:t>
+              <a:t>10/24/2026</a:t>
             </a:fld>
             <a:endParaRPr lang="en-US"/>
           </a:p>
@@ -3238,7 +3016,7 @@
           <a:p>
             <a:fld id="{5BCAD085-E8A6-8845-BD4E-CB4CCA059FC4}" type="datetimeFigureOut">
               <a:rPr lang="en-US" smtClean="0"/>
-              <a:t>1/27/13</a:t>
+              <a:t>10/24/2026</a:t>
             </a:fld>
             <a:endParaRPr lang="en-US"/>
           </a:p>
@@ -3341,10 +3119,9 @@
           </a:lstStyle>
           <a:p>
             <a:r>
-              <a:rPr lang="en-US" smtClean="0"/>
+              <a:rPr lang="en-US"/>
               <a:t>Click to edit Master title style</a:t>
             </a:r>
-            <a:endParaRPr lang="en-US"/>
           </a:p>
         </p:txBody>
       </p:sp>
@@ -3398,38 +3175,37 @@
           <a:p>
             <a:pPr lvl="0"/>
             <a:r>
-              <a:rPr lang="en-US" smtClean="0"/>
+              <a:rPr lang="en-US"/>
               <a:t>Click to edit Master text styles</a:t>
             </a:r>
           </a:p>
           <a:p>
             <a:pPr lvl="1"/>
             <a:r>
-              <a:rPr lang="en-US" smtClean="0"/>
+              <a:rPr lang="en-US"/>
               <a:t>Second level</a:t>
             </a:r>
           </a:p>
           <a:p>
             <a:pPr lvl="2"/>
             <a:r>
-              <a:rPr lang="en-US" smtClean="0"/>
+              <a:rPr lang="en-US"/>
               <a:t>Third level</a:t>
             </a:r>
           </a:p>
           <a:p>
             <a:pPr lvl="3"/>
             <a:r>
-              <a:rPr lang="en-US" smtClean="0"/>
+              <a:rPr lang="en-US"/>
               <a:t>Fourth level</a:t>
             </a:r>
           </a:p>
           <a:p>
             <a:pPr lvl="4"/>
             <a:r>
-              <a:rPr lang="en-US" smtClean="0"/>
+              <a:rPr lang="en-US"/>
               <a:t>Fifth level</a:t>
             </a:r>
-            <a:endParaRPr lang="en-US"/>
           </a:p>
         </p:txBody>
       </p:sp>
@@ -3492,7 +3268,7 @@
           <a:p>
             <a:pPr lvl="0"/>
             <a:r>
-              <a:rPr lang="en-US" smtClean="0"/>
+              <a:rPr lang="en-US"/>
               <a:t>Click to edit Master text styles</a:t>
             </a:r>
           </a:p>
@@ -3515,7 +3291,7 @@
           <a:p>
             <a:fld id="{5BCAD085-E8A6-8845-BD4E-CB4CCA059FC4}" type="datetimeFigureOut">
               <a:rPr lang="en-US" smtClean="0"/>
-              <a:t>1/27/13</a:t>
+              <a:t>10/24/2026</a:t>
             </a:fld>
             <a:endParaRPr lang="en-US"/>
           </a:p>
@@ -3618,10 +3394,9 @@
           </a:lstStyle>
           <a:p>
             <a:r>
-              <a:rPr lang="en-US" smtClean="0"/>
+              <a:rPr lang="en-US"/>
               <a:t>Click to edit Master title style</a:t>
             </a:r>
-            <a:endParaRPr lang="en-US"/>
           </a:p>
         </p:txBody>
       </p:sp>
@@ -3745,7 +3520,7 @@
           <a:p>
             <a:pPr lvl="0"/>
             <a:r>
-              <a:rPr lang="en-US" smtClean="0"/>
+              <a:rPr lang="en-US"/>
               <a:t>Click to edit Master text styles</a:t>
             </a:r>
           </a:p>
@@ -3768,7 +3543,7 @@
           <a:p>
             <a:fld id="{5BCAD085-E8A6-8845-BD4E-CB4CCA059FC4}" type="datetimeFigureOut">
               <a:rPr lang="en-US" smtClean="0"/>
-              <a:t>1/27/13</a:t>
+              <a:t>10/24/2026</a:t>
             </a:fld>
             <a:endParaRPr lang="en-US"/>
           </a:p>
@@ -3877,10 +3652,9 @@
           <a:lstStyle/>
           <a:p>
             <a:r>
-              <a:rPr lang="en-US" smtClean="0"/>
+              <a:rPr lang="en-US"/>
               <a:t>Click to edit Master title style</a:t>
             </a:r>
-            <a:endParaRPr lang="en-US"/>
           </a:p>
         </p:txBody>
       </p:sp>
@@ -3911,38 +3685,37 @@
           <a:p>
             <a:pPr lvl="0"/>
             <a:r>
-              <a:rPr lang="en-US" smtClean="0"/>
+              <a:rPr lang="en-US"/>
               <a:t>Click to edit Master text styles</a:t>
             </a:r>
           </a:p>
           <a:p>
             <a:pPr lvl="1"/>
             <a:r>
-              <a:rPr lang="en-US" smtClean="0"/>
+              <a:rPr lang="en-US"/>
               <a:t>Second level</a:t>
             </a:r>
           </a:p>
           <a:p>
             <a:pPr lvl="2"/>
             <a:r>
-              <a:rPr lang="en-US" smtClean="0"/>
+              <a:rPr lang="en-US"/>
               <a:t>Third level</a:t>
             </a:r>
           </a:p>
           <a:p>
             <a:pPr lvl="3"/>
             <a:r>
-              <a:rPr lang="en-US" smtClean="0"/>
+              <a:rPr lang="en-US"/>
               <a:t>Fourth level</a:t>
             </a:r>
           </a:p>
           <a:p>
             <a:pPr lvl="4"/>
             <a:r>
-              <a:rPr lang="en-US" smtClean="0"/>
+              <a:rPr lang="en-US"/>
               <a:t>Fifth level</a:t>
             </a:r>
-            <a:endParaRPr lang="en-US"/>
           </a:p>
         </p:txBody>
       </p:sp>
@@ -3981,7 +3754,7 @@
           <a:p>
             <a:fld id="{5BCAD085-E8A6-8845-BD4E-CB4CCA059FC4}" type="datetimeFigureOut">
               <a:rPr lang="en-US" smtClean="0"/>
-              <a:t>1/27/13</a:t>
+              <a:t>10/24/2026</a:t>
             </a:fld>
             <a:endParaRPr lang="en-US"/>
           </a:p>
@@ -4340,7 +4113,7 @@
 </file>
 
 <file path=ppt/slides/slide1.xml><?xml version="1.0" encoding="utf-8"?>
-<p:sld xmlns:a="http://schemas.openxmlformats.org/drawingml/2006/main" xmlns:p="http://schemas.openxmlformats.org/presentationml/2006/main" xmlns:r="http://schemas.openxmlformats.org/officeDocument/2006/relationships">
+<p:sld xmlns:a="http://schemas.openxmlformats.org/drawingml/2006/main" xmlns:r="http://schemas.openxmlformats.org/officeDocument/2006/relationships" xmlns:p="http://schemas.openxmlformats.org/presentationml/2006/main">
   <p:cSld>
     <p:spTree>
       <p:nvGrpSpPr>
@@ -4348,7 +4121,14 @@
         <p:cNvGrpSpPr/>
         <p:nvPr/>
       </p:nvGrpSpPr>
-      <p:grpSpPr/>
+      <p:grpSpPr>
+        <a:xfrm>
+          <a:off x="0" y="0"/>
+          <a:ext cx="0" cy="0"/>
+          <a:chOff x="0" y="0"/>
+          <a:chExt cx="0" cy="0"/>
+        </a:xfrm>
+      </p:grpSpPr>
       <p:sp>
         <p:nvSpPr>
           <p:cNvPr id="2" name="Rectangle 1"/>
@@ -4357,7 +4137,7 @@
         </p:nvSpPr>
         <p:spPr>
           <a:xfrm>
-            <a:off x="0" y="0"/>
+            <a:off x="9144" y="18288"/>
             <a:ext cx="12191695" cy="6858000"/>
           </a:xfrm>
           <a:prstGeom prst="rect">
@@ -4391,33 +4171,10 @@
           <a:lstStyle/>
           <a:p>
             <a:pPr algn="ctr"/>
-          </a:p>
-        </p:txBody>
-      </p:sp>
-      <p:pic>
-        <p:nvPicPr>
-          <p:cNvPr id="3" name="Picture 2" descr="jain_logo.png"/>
-          <p:cNvPicPr>
-            <a:picLocks noChangeAspect="1"/>
-          </p:cNvPicPr>
-          <p:nvPr/>
-        </p:nvPicPr>
-        <p:blipFill>
-          <a:blip r:embed="rId2"/>
-          <a:stretch>
-            <a:fillRect/>
-          </a:stretch>
-        </p:blipFill>
-        <p:spPr>
-          <a:xfrm>
-            <a:off x="731520" y="548640"/>
-            <a:ext cx="3474720" cy="2171222"/>
-          </a:xfrm>
-          <a:prstGeom prst="rect">
-            <a:avLst/>
-          </a:prstGeom>
-        </p:spPr>
-      </p:pic>
+            <a:endParaRPr/>
+          </a:p>
+        </p:txBody>
+      </p:sp>
       <p:sp>
         <p:nvSpPr>
           <p:cNvPr id="4" name="Rounded Rectangle 3"/>
@@ -4426,8 +4183,8 @@
         </p:nvSpPr>
         <p:spPr>
           <a:xfrm>
-            <a:off x="731520" y="1645920"/>
-            <a:ext cx="10728655" cy="2286000"/>
+            <a:off x="457505" y="594360"/>
+            <a:ext cx="10728655" cy="3145536"/>
           </a:xfrm>
           <a:prstGeom prst="roundRect">
             <a:avLst/>
@@ -4460,6 +4217,7 @@
           <a:lstStyle/>
           <a:p>
             <a:pPr algn="ctr"/>
+            <a:endParaRPr/>
           </a:p>
         </p:txBody>
       </p:sp>
@@ -4471,7 +4229,7 @@
         </p:nvSpPr>
         <p:spPr>
           <a:xfrm>
-            <a:off x="1005840" y="1828800"/>
+            <a:off x="731520" y="1005840"/>
             <a:ext cx="10149840" cy="1920240"/>
           </a:xfrm>
           <a:prstGeom prst="rect">
@@ -4494,6 +4252,7 @@
               </a:defRPr>
             </a:pPr>
             <a:r>
+              <a:rPr dirty="0"/>
               <a:t>DISCRETE MATHEMATICS &amp; GRAPH THEORY — EXPERIENTIAL LEARNING</a:t>
             </a:r>
           </a:p>
@@ -4510,6 +4269,7 @@
               </a:defRPr>
             </a:pPr>
             <a:r>
+              <a:rPr dirty="0"/>
               <a:t>Optimal Prefix Codes and Data Compression Using Huffman Coding</a:t>
             </a:r>
           </a:p>
@@ -4526,6 +4286,7 @@
               </a:defRPr>
             </a:pPr>
             <a:r>
+              <a:rPr dirty="0"/>
               <a:t>An Information-Theoretic and Graph-Based Algorithmic Approach to Lossless Encoding</a:t>
             </a:r>
           </a:p>
@@ -4573,6 +4334,7 @@
           <a:lstStyle/>
           <a:p>
             <a:pPr algn="ctr"/>
+            <a:endParaRPr/>
           </a:p>
         </p:txBody>
       </p:sp>
@@ -4585,7 +4347,7 @@
         <p:spPr>
           <a:xfrm>
             <a:off x="914400" y="4206240"/>
-            <a:ext cx="4754880" cy="2011680"/>
+            <a:ext cx="4754880" cy="1679947"/>
           </a:xfrm>
           <a:prstGeom prst="rect">
             <a:avLst/>
@@ -4607,6 +4369,7 @@
               </a:defRPr>
             </a:pPr>
             <a:r>
+              <a:rPr sz="1600" dirty="0"/>
               <a:t>ACADEMIC EVALUATION DETAILS</a:t>
             </a:r>
           </a:p>
@@ -4622,18 +4385,28 @@
               </a:defRPr>
             </a:pPr>
             <a:r>
+              <a:rPr sz="1400" dirty="0"/>
               <a:t>Submitted to:</a:t>
             </a:r>
-            <a:br/>
-            <a:r>
+            <a:br>
+              <a:rPr sz="1400" dirty="0"/>
+            </a:br>
+            <a:r>
+              <a:rPr sz="1400" dirty="0"/>
               <a:t>Dr. Priya Satish</a:t>
             </a:r>
-            <a:br/>
-            <a:r>
+            <a:br>
+              <a:rPr sz="1400" dirty="0"/>
+            </a:br>
+            <a:r>
+              <a:rPr sz="1400" dirty="0"/>
               <a:t>Assistant Professor, Department of Mathematics</a:t>
             </a:r>
-            <a:br/>
-            <a:r>
+            <a:br>
+              <a:rPr sz="1400" dirty="0"/>
+            </a:br>
+            <a:r>
+              <a:rPr sz="1400" dirty="0"/>
               <a:t>Faculty of Engineering &amp; Technology, JAIN (Deemed-to-be University)</a:t>
             </a:r>
           </a:p>
@@ -4649,6 +4422,7 @@
               </a:defRPr>
             </a:pPr>
             <a:r>
+              <a:rPr sz="1100" dirty="0"/>
               <a:t>Branch: CSE - BLOCKCHAIN  •  Date: 10-11-2026</a:t>
             </a:r>
           </a:p>
@@ -4696,6 +4470,7 @@
           <a:lstStyle/>
           <a:p>
             <a:pPr algn="ctr"/>
+            <a:endParaRPr/>
           </a:p>
         </p:txBody>
       </p:sp>
@@ -4708,7 +4483,7 @@
         <p:spPr>
           <a:xfrm>
             <a:off x="6217920" y="4206240"/>
-            <a:ext cx="5029200" cy="2011680"/>
+            <a:ext cx="5029200" cy="1446550"/>
           </a:xfrm>
           <a:prstGeom prst="rect">
             <a:avLst/>
@@ -4730,6 +4505,7 @@
               </a:defRPr>
             </a:pPr>
             <a:r>
+              <a:rPr sz="1100" dirty="0"/>
               <a:t>SUBMITTED BY (TEAM MEMBERS):</a:t>
             </a:r>
           </a:p>
@@ -4745,6 +4521,7 @@
               </a:defRPr>
             </a:pPr>
             <a:r>
+              <a:rPr sz="1200" dirty="0"/>
               <a:t>• Nikhil Kumar (25BTRBT026)  —  Project Lead &amp; Core Implementation</a:t>
             </a:r>
           </a:p>
@@ -4760,6 +4537,7 @@
               </a:defRPr>
             </a:pPr>
             <a:r>
+              <a:rPr sz="1200" dirty="0"/>
               <a:t>• Piyush Kumar (25BTRBT030)  —  Encoder/Decoder &amp; Verification</a:t>
             </a:r>
           </a:p>
@@ -4775,6 +4553,7 @@
               </a:defRPr>
             </a:pPr>
             <a:r>
+              <a:rPr sz="1200" dirty="0"/>
               <a:t>• Sakshi Kumari (25BTRC0045)  —  Mathematical Formulation &amp; Theory</a:t>
             </a:r>
           </a:p>
@@ -4790,7 +4569,16 @@
               </a:defRPr>
             </a:pPr>
             <a:r>
-              <a:t>• Arushi Pramanik (25BTRBT008)  —  Dataset Collection &amp; Preprocessing</a:t>
+              <a:rPr sz="1200" dirty="0"/>
+              <a:t>• Arushi </a:t>
+            </a:r>
+            <a:r>
+              <a:rPr sz="1200" dirty="0" err="1"/>
+              <a:t>Pramanik</a:t>
+            </a:r>
+            <a:r>
+              <a:rPr sz="1200" dirty="0"/>
+              <a:t> (25BTRBT008)  —  Dataset Collection &amp; Preprocessing</a:t>
             </a:r>
           </a:p>
           <a:p>
@@ -4805,6 +4593,7 @@
               </a:defRPr>
             </a:pPr>
             <a:r>
+              <a:rPr sz="1200" dirty="0"/>
               <a:t>• Harsh R Rao (25BTRBT017)  —  Experimental Design &amp; Benchmarking</a:t>
             </a:r>
           </a:p>
@@ -4820,7 +4609,16 @@
               </a:defRPr>
             </a:pPr>
             <a:r>
-              <a:t>• Khyathi Jain (25BTRBT021)  —  Visualization &amp; Presentation</a:t>
+              <a:rPr sz="1200" dirty="0"/>
+              <a:t>• </a:t>
+            </a:r>
+            <a:r>
+              <a:rPr sz="1200" dirty="0" err="1"/>
+              <a:t>Khyathi</a:t>
+            </a:r>
+            <a:r>
+              <a:rPr sz="1200" dirty="0"/>
+              <a:t> Jain (25BTRBT021)  —  Visualization &amp; Presentation</a:t>
             </a:r>
           </a:p>
         </p:txBody>
@@ -4834,7 +4632,7 @@
 </file>
 
 <file path=ppt/slides/slide10.xml><?xml version="1.0" encoding="utf-8"?>
-<p:sld xmlns:a="http://schemas.openxmlformats.org/drawingml/2006/main" xmlns:p="http://schemas.openxmlformats.org/presentationml/2006/main" xmlns:r="http://schemas.openxmlformats.org/officeDocument/2006/relationships">
+<p:sld xmlns:a="http://schemas.openxmlformats.org/drawingml/2006/main" xmlns:r="http://schemas.openxmlformats.org/officeDocument/2006/relationships" xmlns:p="http://schemas.openxmlformats.org/presentationml/2006/main">
   <p:cSld>
     <p:spTree>
       <p:nvGrpSpPr>
@@ -4842,7 +4640,14 @@
         <p:cNvGrpSpPr/>
         <p:nvPr/>
       </p:nvGrpSpPr>
-      <p:grpSpPr/>
+      <p:grpSpPr>
+        <a:xfrm>
+          <a:off x="0" y="0"/>
+          <a:ext cx="0" cy="0"/>
+          <a:chOff x="0" y="0"/>
+          <a:chExt cx="0" cy="0"/>
+        </a:xfrm>
+      </p:grpSpPr>
       <p:sp>
         <p:nvSpPr>
           <p:cNvPr id="2" name="Rectangle 1"/>
@@ -4885,6 +4690,7 @@
           <a:lstStyle/>
           <a:p>
             <a:pPr algn="ctr"/>
+            <a:endParaRPr/>
           </a:p>
         </p:txBody>
       </p:sp>
@@ -5035,76 +4841,6 @@
       <p:pic>
         <p:nvPicPr>
           <p:cNvPr id="7" name="Picture 6" descr="huffman_tree_visualization.png"/>
-          <p:cNvPicPr>
-            <a:picLocks noChangeAspect="1"/>
-          </p:cNvPicPr>
-          <p:nvPr/>
-        </p:nvPicPr>
-        <p:blipFill>
-          <a:blip r:embed="rId2"/>
-          <a:stretch>
-            <a:fillRect/>
-          </a:stretch>
-        </p:blipFill>
-        <p:spPr>
-          <a:xfrm>
-            <a:off x="731520" y="1280160"/>
-            <a:ext cx="5212080" cy="2962261"/>
-          </a:xfrm>
-          <a:prstGeom prst="rect">
-            <a:avLst/>
-          </a:prstGeom>
-        </p:spPr>
-      </p:pic>
-      <p:sp>
-        <p:nvSpPr>
-          <p:cNvPr id="8" name="TextBox 7"/>
-          <p:cNvSpPr txBox="1"/>
-          <p:nvPr/>
-        </p:nvSpPr>
-        <p:spPr>
-          <a:xfrm>
-            <a:off x="731520" y="5212080"/>
-            <a:ext cx="5212080" cy="1097280"/>
-          </a:xfrm>
-          <a:prstGeom prst="rect">
-            <a:avLst/>
-          </a:prstGeom>
-          <a:noFill/>
-        </p:spPr>
-        <p:txBody>
-          <a:bodyPr wrap="square">
-            <a:spAutoFit/>
-          </a:bodyPr>
-          <a:lstStyle/>
-          <a:p>
-            <a:pPr>
-              <a:defRPr sz="1000" b="1">
-                <a:solidFill>
-                  <a:srgbClr val="102C57"/>
-                </a:solidFill>
-              </a:defRPr>
-            </a:pPr>
-            <a:r>
-              <a:t>NetworkX Tree Visualization (Khyathi Jain):</a:t>
-            </a:r>
-          </a:p>
-          <a:p>
-            <a:pPr>
-              <a:spcBef>
-                <a:spcPts val="200"/>
-              </a:spcBef>
-              <a:defRPr sz="850"/>
-            </a:pPr>
-            <a:r>
-              <a:t>Visualizes rooted binary tree: Blue circles = internal nodes (merged weights); Green squares = leaf symbols. Red edge labels '0' (left) and '1' (right) trace prefix paths.</a:t>
-            </a:r>
-          </a:p>
-        </p:txBody>
-      </p:sp>
-      <p:pic>
-        <p:nvPicPr>
-          <p:cNvPr id="9" name="Picture 8" descr="exp2_runtime_scaling.png"/>
           <p:cNvPicPr>
             <a:picLocks noChangeAspect="1"/>
           </p:cNvPicPr>
@@ -5118,6 +4854,76 @@
         </p:blipFill>
         <p:spPr>
           <a:xfrm>
+            <a:off x="731520" y="1280160"/>
+            <a:ext cx="5212080" cy="2962261"/>
+          </a:xfrm>
+          <a:prstGeom prst="rect">
+            <a:avLst/>
+          </a:prstGeom>
+        </p:spPr>
+      </p:pic>
+      <p:sp>
+        <p:nvSpPr>
+          <p:cNvPr id="8" name="TextBox 7"/>
+          <p:cNvSpPr txBox="1"/>
+          <p:nvPr/>
+        </p:nvSpPr>
+        <p:spPr>
+          <a:xfrm>
+            <a:off x="731520" y="5212080"/>
+            <a:ext cx="5212080" cy="1097280"/>
+          </a:xfrm>
+          <a:prstGeom prst="rect">
+            <a:avLst/>
+          </a:prstGeom>
+          <a:noFill/>
+        </p:spPr>
+        <p:txBody>
+          <a:bodyPr wrap="square">
+            <a:spAutoFit/>
+          </a:bodyPr>
+          <a:lstStyle/>
+          <a:p>
+            <a:pPr>
+              <a:defRPr sz="1000" b="1">
+                <a:solidFill>
+                  <a:srgbClr val="102C57"/>
+                </a:solidFill>
+              </a:defRPr>
+            </a:pPr>
+            <a:r>
+              <a:t>NetworkX Tree Visualization (Khyathi Jain):</a:t>
+            </a:r>
+          </a:p>
+          <a:p>
+            <a:pPr>
+              <a:spcBef>
+                <a:spcPts val="200"/>
+              </a:spcBef>
+              <a:defRPr sz="850"/>
+            </a:pPr>
+            <a:r>
+              <a:t>Visualizes rooted binary tree: Blue circles = internal nodes (merged weights); Green squares = leaf symbols. Red edge labels '0' (left) and '1' (right) trace prefix paths.</a:t>
+            </a:r>
+          </a:p>
+        </p:txBody>
+      </p:sp>
+      <p:pic>
+        <p:nvPicPr>
+          <p:cNvPr id="9" name="Picture 8" descr="exp2_runtime_scaling.png"/>
+          <p:cNvPicPr>
+            <a:picLocks noChangeAspect="1"/>
+          </p:cNvPicPr>
+          <p:nvPr/>
+        </p:nvPicPr>
+        <p:blipFill>
+          <a:blip r:embed="rId4"/>
+          <a:stretch>
+            <a:fillRect/>
+          </a:stretch>
+        </p:blipFill>
+        <p:spPr>
+          <a:xfrm>
             <a:off x="6217920" y="1280160"/>
             <a:ext cx="5242255" cy="2912364"/>
           </a:xfrm>
@@ -5181,7 +4987,7 @@
 </file>
 
 <file path=ppt/slides/slide11.xml><?xml version="1.0" encoding="utf-8"?>
-<p:sld xmlns:a="http://schemas.openxmlformats.org/drawingml/2006/main" xmlns:p="http://schemas.openxmlformats.org/presentationml/2006/main" xmlns:r="http://schemas.openxmlformats.org/officeDocument/2006/relationships">
+<p:sld xmlns:a="http://schemas.openxmlformats.org/drawingml/2006/main" xmlns:r="http://schemas.openxmlformats.org/officeDocument/2006/relationships" xmlns:p="http://schemas.openxmlformats.org/presentationml/2006/main">
   <p:cSld>
     <p:spTree>
       <p:nvGrpSpPr>
@@ -5189,7 +4995,14 @@
         <p:cNvGrpSpPr/>
         <p:nvPr/>
       </p:nvGrpSpPr>
-      <p:grpSpPr/>
+      <p:grpSpPr>
+        <a:xfrm>
+          <a:off x="0" y="0"/>
+          <a:ext cx="0" cy="0"/>
+          <a:chOff x="0" y="0"/>
+          <a:chExt cx="0" cy="0"/>
+        </a:xfrm>
+      </p:grpSpPr>
       <p:sp>
         <p:nvSpPr>
           <p:cNvPr id="2" name="Rectangle 1"/>
@@ -5232,6 +5045,7 @@
           <a:lstStyle/>
           <a:p>
             <a:pPr algn="ctr"/>
+            <a:endParaRPr/>
           </a:p>
         </p:txBody>
       </p:sp>
@@ -5398,9 +5212,27 @@
                 <a:tableStyleId>{5C22544A-7EE6-4342-B048-85BDC9FD1C3A}</a:tableStyleId>
               </a:tblPr>
               <a:tblGrid>
-                <a:gridCol w="2011680"/>
-                <a:gridCol w="3931920"/>
-                <a:gridCol w="4785055"/>
+                <a:gridCol w="2011680">
+                  <a:extLst>
+                    <a:ext uri="{9D8B030D-6E8A-4147-A177-3AD203B41FA5}">
+                      <a16:colId xmlns:a16="http://schemas.microsoft.com/office/drawing/2014/main" val="20000"/>
+                    </a:ext>
+                  </a:extLst>
+                </a:gridCol>
+                <a:gridCol w="3931920">
+                  <a:extLst>
+                    <a:ext uri="{9D8B030D-6E8A-4147-A177-3AD203B41FA5}">
+                      <a16:colId xmlns:a16="http://schemas.microsoft.com/office/drawing/2014/main" val="20001"/>
+                    </a:ext>
+                  </a:extLst>
+                </a:gridCol>
+                <a:gridCol w="4785055">
+                  <a:extLst>
+                    <a:ext uri="{9D8B030D-6E8A-4147-A177-3AD203B41FA5}">
+                      <a16:colId xmlns:a16="http://schemas.microsoft.com/office/drawing/2014/main" val="20002"/>
+                    </a:ext>
+                  </a:extLst>
+                </a:gridCol>
               </a:tblGrid>
               <a:tr h="538480">
                 <a:tc>
@@ -5472,6 +5304,11 @@
                     </a:solidFill>
                   </a:tcPr>
                 </a:tc>
+                <a:extLst>
+                  <a:ext uri="{0D108BD9-81ED-4DB2-BD59-A6C34878D82A}">
+                    <a16:rowId xmlns:a16="http://schemas.microsoft.com/office/drawing/2014/main" val="10000"/>
+                  </a:ext>
+                </a:extLst>
               </a:tr>
               <a:tr h="538480">
                 <a:tc>
@@ -5543,6 +5380,11 @@
                     </a:solidFill>
                   </a:tcPr>
                 </a:tc>
+                <a:extLst>
+                  <a:ext uri="{0D108BD9-81ED-4DB2-BD59-A6C34878D82A}">
+                    <a16:rowId xmlns:a16="http://schemas.microsoft.com/office/drawing/2014/main" val="10001"/>
+                  </a:ext>
+                </a:extLst>
               </a:tr>
               <a:tr h="538480">
                 <a:tc>
@@ -5614,6 +5456,11 @@
                     </a:solidFill>
                   </a:tcPr>
                 </a:tc>
+                <a:extLst>
+                  <a:ext uri="{0D108BD9-81ED-4DB2-BD59-A6C34878D82A}">
+                    <a16:rowId xmlns:a16="http://schemas.microsoft.com/office/drawing/2014/main" val="10002"/>
+                  </a:ext>
+                </a:extLst>
               </a:tr>
               <a:tr h="538480">
                 <a:tc>
@@ -5685,6 +5532,11 @@
                     </a:solidFill>
                   </a:tcPr>
                 </a:tc>
+                <a:extLst>
+                  <a:ext uri="{0D108BD9-81ED-4DB2-BD59-A6C34878D82A}">
+                    <a16:rowId xmlns:a16="http://schemas.microsoft.com/office/drawing/2014/main" val="10003"/>
+                  </a:ext>
+                </a:extLst>
               </a:tr>
               <a:tr h="538480">
                 <a:tc>
@@ -5756,6 +5608,11 @@
                     </a:solidFill>
                   </a:tcPr>
                 </a:tc>
+                <a:extLst>
+                  <a:ext uri="{0D108BD9-81ED-4DB2-BD59-A6C34878D82A}">
+                    <a16:rowId xmlns:a16="http://schemas.microsoft.com/office/drawing/2014/main" val="10004"/>
+                  </a:ext>
+                </a:extLst>
               </a:tr>
               <a:tr h="538480">
                 <a:tc>
@@ -5827,6 +5684,11 @@
                     </a:solidFill>
                   </a:tcPr>
                 </a:tc>
+                <a:extLst>
+                  <a:ext uri="{0D108BD9-81ED-4DB2-BD59-A6C34878D82A}">
+                    <a16:rowId xmlns:a16="http://schemas.microsoft.com/office/drawing/2014/main" val="10005"/>
+                  </a:ext>
+                </a:extLst>
               </a:tr>
               <a:tr h="538480">
                 <a:tc>
@@ -5898,6 +5760,11 @@
                     </a:solidFill>
                   </a:tcPr>
                 </a:tc>
+                <a:extLst>
+                  <a:ext uri="{0D108BD9-81ED-4DB2-BD59-A6C34878D82A}">
+                    <a16:rowId xmlns:a16="http://schemas.microsoft.com/office/drawing/2014/main" val="10006"/>
+                  </a:ext>
+                </a:extLst>
               </a:tr>
               <a:tr h="538480">
                 <a:tc>
@@ -5969,6 +5836,11 @@
                     </a:solidFill>
                   </a:tcPr>
                 </a:tc>
+                <a:extLst>
+                  <a:ext uri="{0D108BD9-81ED-4DB2-BD59-A6C34878D82A}">
+                    <a16:rowId xmlns:a16="http://schemas.microsoft.com/office/drawing/2014/main" val="10007"/>
+                  </a:ext>
+                </a:extLst>
               </a:tr>
               <a:tr h="538480">
                 <a:tc>
@@ -6040,6 +5912,11 @@
                     </a:solidFill>
                   </a:tcPr>
                 </a:tc>
+                <a:extLst>
+                  <a:ext uri="{0D108BD9-81ED-4DB2-BD59-A6C34878D82A}">
+                    <a16:rowId xmlns:a16="http://schemas.microsoft.com/office/drawing/2014/main" val="10008"/>
+                  </a:ext>
+                </a:extLst>
               </a:tr>
             </a:tbl>
           </a:graphicData>
@@ -6054,7 +5931,7 @@
 </file>
 
 <file path=ppt/slides/slide12.xml><?xml version="1.0" encoding="utf-8"?>
-<p:sld xmlns:a="http://schemas.openxmlformats.org/drawingml/2006/main" xmlns:p="http://schemas.openxmlformats.org/presentationml/2006/main" xmlns:r="http://schemas.openxmlformats.org/officeDocument/2006/relationships">
+<p:sld xmlns:a="http://schemas.openxmlformats.org/drawingml/2006/main" xmlns:r="http://schemas.openxmlformats.org/officeDocument/2006/relationships" xmlns:p="http://schemas.openxmlformats.org/presentationml/2006/main">
   <p:cSld>
     <p:spTree>
       <p:nvGrpSpPr>
@@ -6062,7 +5939,14 @@
         <p:cNvGrpSpPr/>
         <p:nvPr/>
       </p:nvGrpSpPr>
-      <p:grpSpPr/>
+      <p:grpSpPr>
+        <a:xfrm>
+          <a:off x="0" y="0"/>
+          <a:ext cx="0" cy="0"/>
+          <a:chOff x="0" y="0"/>
+          <a:chExt cx="0" cy="0"/>
+        </a:xfrm>
+      </p:grpSpPr>
       <p:sp>
         <p:nvSpPr>
           <p:cNvPr id="2" name="Rectangle 1"/>
@@ -6105,6 +5989,7 @@
           <a:lstStyle/>
           <a:p>
             <a:pPr algn="ctr"/>
+            <a:endParaRPr/>
           </a:p>
         </p:txBody>
       </p:sp>
@@ -6294,6 +6179,7 @@
           <a:lstStyle/>
           <a:p>
             <a:pPr algn="ctr"/>
+            <a:endParaRPr/>
           </a:p>
         </p:txBody>
       </p:sp>
@@ -6450,6 +6336,7 @@
           <a:lstStyle/>
           <a:p>
             <a:pPr algn="ctr"/>
+            <a:endParaRPr/>
           </a:p>
         </p:txBody>
       </p:sp>
@@ -6557,7 +6444,7 @@
 </file>
 
 <file path=ppt/slides/slide2.xml><?xml version="1.0" encoding="utf-8"?>
-<p:sld xmlns:a="http://schemas.openxmlformats.org/drawingml/2006/main" xmlns:p="http://schemas.openxmlformats.org/presentationml/2006/main" xmlns:r="http://schemas.openxmlformats.org/officeDocument/2006/relationships">
+<p:sld xmlns:a="http://schemas.openxmlformats.org/drawingml/2006/main" xmlns:r="http://schemas.openxmlformats.org/officeDocument/2006/relationships" xmlns:p="http://schemas.openxmlformats.org/presentationml/2006/main">
   <p:cSld>
     <p:spTree>
       <p:nvGrpSpPr>
@@ -6565,7 +6452,14 @@
         <p:cNvGrpSpPr/>
         <p:nvPr/>
       </p:nvGrpSpPr>
-      <p:grpSpPr/>
+      <p:grpSpPr>
+        <a:xfrm>
+          <a:off x="0" y="0"/>
+          <a:ext cx="0" cy="0"/>
+          <a:chOff x="0" y="0"/>
+          <a:chExt cx="0" cy="0"/>
+        </a:xfrm>
+      </p:grpSpPr>
       <p:sp>
         <p:nvSpPr>
           <p:cNvPr id="2" name="Rectangle 1"/>
@@ -6608,6 +6502,7 @@
           <a:lstStyle/>
           <a:p>
             <a:pPr algn="ctr"/>
+            <a:endParaRPr/>
           </a:p>
         </p:txBody>
       </p:sp>
@@ -6797,6 +6692,7 @@
           <a:lstStyle/>
           <a:p>
             <a:pPr algn="ctr"/>
+            <a:endParaRPr/>
           </a:p>
         </p:txBody>
       </p:sp>
@@ -6842,6 +6738,7 @@
           <a:lstStyle/>
           <a:p>
             <a:pPr algn="ctr"/>
+            <a:endParaRPr/>
           </a:p>
         </p:txBody>
       </p:sp>
@@ -7017,6 +6914,7 @@
           <a:lstStyle/>
           <a:p>
             <a:pPr algn="ctr"/>
+            <a:endParaRPr/>
           </a:p>
         </p:txBody>
       </p:sp>
@@ -7062,6 +6960,7 @@
           <a:lstStyle/>
           <a:p>
             <a:pPr algn="ctr"/>
+            <a:endParaRPr/>
           </a:p>
         </p:txBody>
       </p:sp>
@@ -7237,6 +7136,7 @@
           <a:lstStyle/>
           <a:p>
             <a:pPr algn="ctr"/>
+            <a:endParaRPr/>
           </a:p>
         </p:txBody>
       </p:sp>
@@ -7282,6 +7182,7 @@
           <a:lstStyle/>
           <a:p>
             <a:pPr algn="ctr"/>
+            <a:endParaRPr/>
           </a:p>
         </p:txBody>
       </p:sp>
@@ -7457,6 +7358,7 @@
           <a:lstStyle/>
           <a:p>
             <a:pPr algn="ctr"/>
+            <a:endParaRPr/>
           </a:p>
         </p:txBody>
       </p:sp>
@@ -7502,6 +7404,7 @@
           <a:lstStyle/>
           <a:p>
             <a:pPr algn="ctr"/>
+            <a:endParaRPr/>
           </a:p>
         </p:txBody>
       </p:sp>
@@ -7677,6 +7580,7 @@
           <a:lstStyle/>
           <a:p>
             <a:pPr algn="ctr"/>
+            <a:endParaRPr/>
           </a:p>
         </p:txBody>
       </p:sp>
@@ -7722,6 +7626,7 @@
           <a:lstStyle/>
           <a:p>
             <a:pPr algn="ctr"/>
+            <a:endParaRPr/>
           </a:p>
         </p:txBody>
       </p:sp>
@@ -7897,6 +7802,7 @@
           <a:lstStyle/>
           <a:p>
             <a:pPr algn="ctr"/>
+            <a:endParaRPr/>
           </a:p>
         </p:txBody>
       </p:sp>
@@ -7942,6 +7848,7 @@
           <a:lstStyle/>
           <a:p>
             <a:pPr algn="ctr"/>
+            <a:endParaRPr/>
           </a:p>
         </p:txBody>
       </p:sp>
@@ -8084,7 +7991,7 @@
 </file>
 
 <file path=ppt/slides/slide3.xml><?xml version="1.0" encoding="utf-8"?>
-<p:sld xmlns:a="http://schemas.openxmlformats.org/drawingml/2006/main" xmlns:p="http://schemas.openxmlformats.org/presentationml/2006/main" xmlns:r="http://schemas.openxmlformats.org/officeDocument/2006/relationships">
+<p:sld xmlns:a="http://schemas.openxmlformats.org/drawingml/2006/main" xmlns:r="http://schemas.openxmlformats.org/officeDocument/2006/relationships" xmlns:p="http://schemas.openxmlformats.org/presentationml/2006/main">
   <p:cSld>
     <p:spTree>
       <p:nvGrpSpPr>
@@ -8092,7 +7999,14 @@
         <p:cNvGrpSpPr/>
         <p:nvPr/>
       </p:nvGrpSpPr>
-      <p:grpSpPr/>
+      <p:grpSpPr>
+        <a:xfrm>
+          <a:off x="0" y="0"/>
+          <a:ext cx="0" cy="0"/>
+          <a:chOff x="0" y="0"/>
+          <a:chExt cx="0" cy="0"/>
+        </a:xfrm>
+      </p:grpSpPr>
       <p:sp>
         <p:nvSpPr>
           <p:cNvPr id="2" name="Rectangle 1"/>
@@ -8135,6 +8049,7 @@
           <a:lstStyle/>
           <a:p>
             <a:pPr algn="ctr"/>
+            <a:endParaRPr/>
           </a:p>
         </p:txBody>
       </p:sp>
@@ -8324,6 +8239,7 @@
           <a:lstStyle/>
           <a:p>
             <a:pPr algn="ctr"/>
+            <a:endParaRPr/>
           </a:p>
         </p:txBody>
       </p:sp>
@@ -8468,6 +8384,7 @@
           <a:lstStyle/>
           <a:p>
             <a:pPr algn="ctr"/>
+            <a:endParaRPr/>
           </a:p>
         </p:txBody>
       </p:sp>
@@ -8593,7 +8510,7 @@
 </file>
 
 <file path=ppt/slides/slide4.xml><?xml version="1.0" encoding="utf-8"?>
-<p:sld xmlns:a="http://schemas.openxmlformats.org/drawingml/2006/main" xmlns:p="http://schemas.openxmlformats.org/presentationml/2006/main" xmlns:r="http://schemas.openxmlformats.org/officeDocument/2006/relationships">
+<p:sld xmlns:a="http://schemas.openxmlformats.org/drawingml/2006/main" xmlns:r="http://schemas.openxmlformats.org/officeDocument/2006/relationships" xmlns:p="http://schemas.openxmlformats.org/presentationml/2006/main">
   <p:cSld>
     <p:spTree>
       <p:nvGrpSpPr>
@@ -8601,7 +8518,14 @@
         <p:cNvGrpSpPr/>
         <p:nvPr/>
       </p:nvGrpSpPr>
-      <p:grpSpPr/>
+      <p:grpSpPr>
+        <a:xfrm>
+          <a:off x="0" y="0"/>
+          <a:ext cx="0" cy="0"/>
+          <a:chOff x="0" y="0"/>
+          <a:chExt cx="0" cy="0"/>
+        </a:xfrm>
+      </p:grpSpPr>
       <p:sp>
         <p:nvSpPr>
           <p:cNvPr id="2" name="Rectangle 1"/>
@@ -8644,6 +8568,7 @@
           <a:lstStyle/>
           <a:p>
             <a:pPr algn="ctr"/>
+            <a:endParaRPr/>
           </a:p>
         </p:txBody>
       </p:sp>
@@ -8833,6 +8758,7 @@
           <a:lstStyle/>
           <a:p>
             <a:pPr algn="ctr"/>
+            <a:endParaRPr/>
           </a:p>
         </p:txBody>
       </p:sp>
@@ -9063,6 +8989,7 @@
           <a:lstStyle/>
           <a:p>
             <a:pPr algn="ctr"/>
+            <a:endParaRPr/>
           </a:p>
         </p:txBody>
       </p:sp>
@@ -9242,7 +9169,7 @@
 </file>
 
 <file path=ppt/slides/slide5.xml><?xml version="1.0" encoding="utf-8"?>
-<p:sld xmlns:a="http://schemas.openxmlformats.org/drawingml/2006/main" xmlns:p="http://schemas.openxmlformats.org/presentationml/2006/main" xmlns:r="http://schemas.openxmlformats.org/officeDocument/2006/relationships">
+<p:sld xmlns:a="http://schemas.openxmlformats.org/drawingml/2006/main" xmlns:r="http://schemas.openxmlformats.org/officeDocument/2006/relationships" xmlns:p="http://schemas.openxmlformats.org/presentationml/2006/main">
   <p:cSld>
     <p:spTree>
       <p:nvGrpSpPr>
@@ -9250,7 +9177,14 @@
         <p:cNvGrpSpPr/>
         <p:nvPr/>
       </p:nvGrpSpPr>
-      <p:grpSpPr/>
+      <p:grpSpPr>
+        <a:xfrm>
+          <a:off x="0" y="0"/>
+          <a:ext cx="0" cy="0"/>
+          <a:chOff x="0" y="0"/>
+          <a:chExt cx="0" cy="0"/>
+        </a:xfrm>
+      </p:grpSpPr>
       <p:sp>
         <p:nvSpPr>
           <p:cNvPr id="2" name="Rectangle 1"/>
@@ -9293,6 +9227,7 @@
           <a:lstStyle/>
           <a:p>
             <a:pPr algn="ctr"/>
+            <a:endParaRPr/>
           </a:p>
         </p:txBody>
       </p:sp>
@@ -9482,6 +9417,7 @@
           <a:lstStyle/>
           <a:p>
             <a:pPr algn="ctr"/>
+            <a:endParaRPr/>
           </a:p>
         </p:txBody>
       </p:sp>
@@ -9527,6 +9463,7 @@
           <a:lstStyle/>
           <a:p>
             <a:pPr algn="ctr"/>
+            <a:endParaRPr/>
           </a:p>
         </p:txBody>
       </p:sp>
@@ -9656,6 +9593,7 @@
           <a:lstStyle/>
           <a:p>
             <a:pPr algn="ctr"/>
+            <a:endParaRPr/>
           </a:p>
         </p:txBody>
       </p:sp>
@@ -9701,6 +9639,7 @@
           <a:lstStyle/>
           <a:p>
             <a:pPr algn="ctr"/>
+            <a:endParaRPr/>
           </a:p>
         </p:txBody>
       </p:sp>
@@ -9840,6 +9779,7 @@
           <a:lstStyle/>
           <a:p>
             <a:pPr algn="ctr"/>
+            <a:endParaRPr/>
           </a:p>
         </p:txBody>
       </p:sp>
@@ -9885,6 +9825,7 @@
           <a:lstStyle/>
           <a:p>
             <a:pPr algn="ctr"/>
+            <a:endParaRPr/>
           </a:p>
         </p:txBody>
       </p:sp>
@@ -9985,7 +9926,7 @@
 </file>
 
 <file path=ppt/slides/slide6.xml><?xml version="1.0" encoding="utf-8"?>
-<p:sld xmlns:a="http://schemas.openxmlformats.org/drawingml/2006/main" xmlns:p="http://schemas.openxmlformats.org/presentationml/2006/main" xmlns:r="http://schemas.openxmlformats.org/officeDocument/2006/relationships">
+<p:sld xmlns:a="http://schemas.openxmlformats.org/drawingml/2006/main" xmlns:r="http://schemas.openxmlformats.org/officeDocument/2006/relationships" xmlns:p="http://schemas.openxmlformats.org/presentationml/2006/main">
   <p:cSld>
     <p:spTree>
       <p:nvGrpSpPr>
@@ -9993,7 +9934,14 @@
         <p:cNvGrpSpPr/>
         <p:nvPr/>
       </p:nvGrpSpPr>
-      <p:grpSpPr/>
+      <p:grpSpPr>
+        <a:xfrm>
+          <a:off x="0" y="0"/>
+          <a:ext cx="0" cy="0"/>
+          <a:chOff x="0" y="0"/>
+          <a:chExt cx="0" cy="0"/>
+        </a:xfrm>
+      </p:grpSpPr>
       <p:sp>
         <p:nvSpPr>
           <p:cNvPr id="2" name="Rectangle 1"/>
@@ -10036,6 +9984,7 @@
           <a:lstStyle/>
           <a:p>
             <a:pPr algn="ctr"/>
+            <a:endParaRPr/>
           </a:p>
         </p:txBody>
       </p:sp>
@@ -10225,6 +10174,7 @@
           <a:lstStyle/>
           <a:p>
             <a:pPr algn="ctr"/>
+            <a:endParaRPr/>
           </a:p>
         </p:txBody>
       </p:sp>
@@ -10445,6 +10395,7 @@
           <a:lstStyle/>
           <a:p>
             <a:pPr algn="ctr"/>
+            <a:endParaRPr/>
           </a:p>
         </p:txBody>
       </p:sp>
@@ -10572,7 +10523,7 @@
 </file>
 
 <file path=ppt/slides/slide7.xml><?xml version="1.0" encoding="utf-8"?>
-<p:sld xmlns:a="http://schemas.openxmlformats.org/drawingml/2006/main" xmlns:p="http://schemas.openxmlformats.org/presentationml/2006/main" xmlns:r="http://schemas.openxmlformats.org/officeDocument/2006/relationships">
+<p:sld xmlns:a="http://schemas.openxmlformats.org/drawingml/2006/main" xmlns:r="http://schemas.openxmlformats.org/officeDocument/2006/relationships" xmlns:p="http://schemas.openxmlformats.org/presentationml/2006/main">
   <p:cSld>
     <p:spTree>
       <p:nvGrpSpPr>
@@ -10580,7 +10531,14 @@
         <p:cNvGrpSpPr/>
         <p:nvPr/>
       </p:nvGrpSpPr>
-      <p:grpSpPr/>
+      <p:grpSpPr>
+        <a:xfrm>
+          <a:off x="0" y="0"/>
+          <a:ext cx="0" cy="0"/>
+          <a:chOff x="0" y="0"/>
+          <a:chExt cx="0" cy="0"/>
+        </a:xfrm>
+      </p:grpSpPr>
       <p:sp>
         <p:nvSpPr>
           <p:cNvPr id="2" name="Rectangle 1"/>
@@ -10623,6 +10581,7 @@
           <a:lstStyle/>
           <a:p>
             <a:pPr algn="ctr"/>
+            <a:endParaRPr/>
           </a:p>
         </p:txBody>
       </p:sp>
@@ -10812,6 +10771,7 @@
           <a:lstStyle/>
           <a:p>
             <a:pPr algn="ctr"/>
+            <a:endParaRPr/>
           </a:p>
         </p:txBody>
       </p:sp>
@@ -10972,6 +10932,7 @@
           <a:lstStyle/>
           <a:p>
             <a:pPr algn="ctr"/>
+            <a:endParaRPr/>
           </a:p>
         </p:txBody>
       </p:sp>
@@ -11199,7 +11160,7 @@
 </file>
 
 <file path=ppt/slides/slide8.xml><?xml version="1.0" encoding="utf-8"?>
-<p:sld xmlns:a="http://schemas.openxmlformats.org/drawingml/2006/main" xmlns:p="http://schemas.openxmlformats.org/presentationml/2006/main" xmlns:r="http://schemas.openxmlformats.org/officeDocument/2006/relationships">
+<p:sld xmlns:a="http://schemas.openxmlformats.org/drawingml/2006/main" xmlns:r="http://schemas.openxmlformats.org/officeDocument/2006/relationships" xmlns:p="http://schemas.openxmlformats.org/presentationml/2006/main">
   <p:cSld>
     <p:spTree>
       <p:nvGrpSpPr>
@@ -11207,7 +11168,14 @@
         <p:cNvGrpSpPr/>
         <p:nvPr/>
       </p:nvGrpSpPr>
-      <p:grpSpPr/>
+      <p:grpSpPr>
+        <a:xfrm>
+          <a:off x="0" y="0"/>
+          <a:ext cx="0" cy="0"/>
+          <a:chOff x="0" y="0"/>
+          <a:chExt cx="0" cy="0"/>
+        </a:xfrm>
+      </p:grpSpPr>
       <p:sp>
         <p:nvSpPr>
           <p:cNvPr id="2" name="Rectangle 1"/>
@@ -11250,6 +11218,7 @@
           <a:lstStyle/>
           <a:p>
             <a:pPr algn="ctr"/>
+            <a:endParaRPr/>
           </a:p>
         </p:txBody>
       </p:sp>
@@ -11407,7 +11376,7 @@
         </p:nvGraphicFramePr>
         <p:xfrm>
           <a:off x="731520" y="1371600"/>
-          <a:ext cx="10728655" cy="2468880"/>
+          <a:ext cx="10728655" cy="3358896"/>
         </p:xfrm>
         <a:graphic>
           <a:graphicData uri="http://schemas.openxmlformats.org/drawingml/2006/table">
@@ -11416,11 +11385,41 @@
                 <a:tableStyleId>{5C22544A-7EE6-4342-B048-85BDC9FD1C3A}</a:tableStyleId>
               </a:tblPr>
               <a:tblGrid>
-                <a:gridCol w="1463040"/>
-                <a:gridCol w="3291840"/>
-                <a:gridCol w="1280160"/>
-                <a:gridCol w="1371600"/>
-                <a:gridCol w="3322015"/>
+                <a:gridCol w="1463040">
+                  <a:extLst>
+                    <a:ext uri="{9D8B030D-6E8A-4147-A177-3AD203B41FA5}">
+                      <a16:colId xmlns:a16="http://schemas.microsoft.com/office/drawing/2014/main" val="20000"/>
+                    </a:ext>
+                  </a:extLst>
+                </a:gridCol>
+                <a:gridCol w="3291840">
+                  <a:extLst>
+                    <a:ext uri="{9D8B030D-6E8A-4147-A177-3AD203B41FA5}">
+                      <a16:colId xmlns:a16="http://schemas.microsoft.com/office/drawing/2014/main" val="20001"/>
+                    </a:ext>
+                  </a:extLst>
+                </a:gridCol>
+                <a:gridCol w="1280160">
+                  <a:extLst>
+                    <a:ext uri="{9D8B030D-6E8A-4147-A177-3AD203B41FA5}">
+                      <a16:colId xmlns:a16="http://schemas.microsoft.com/office/drawing/2014/main" val="20002"/>
+                    </a:ext>
+                  </a:extLst>
+                </a:gridCol>
+                <a:gridCol w="1371600">
+                  <a:extLst>
+                    <a:ext uri="{9D8B030D-6E8A-4147-A177-3AD203B41FA5}">
+                      <a16:colId xmlns:a16="http://schemas.microsoft.com/office/drawing/2014/main" val="20003"/>
+                    </a:ext>
+                  </a:extLst>
+                </a:gridCol>
+                <a:gridCol w="3322015">
+                  <a:extLst>
+                    <a:ext uri="{9D8B030D-6E8A-4147-A177-3AD203B41FA5}">
+                      <a16:colId xmlns:a16="http://schemas.microsoft.com/office/drawing/2014/main" val="20004"/>
+                    </a:ext>
+                  </a:extLst>
+                </a:gridCol>
               </a:tblGrid>
               <a:tr h="493776">
                 <a:tc>
@@ -11538,6 +11537,11 @@
                     </a:solidFill>
                   </a:tcPr>
                 </a:tc>
+                <a:extLst>
+                  <a:ext uri="{0D108BD9-81ED-4DB2-BD59-A6C34878D82A}">
+                    <a16:rowId xmlns:a16="http://schemas.microsoft.com/office/drawing/2014/main" val="10000"/>
+                  </a:ext>
+                </a:extLst>
               </a:tr>
               <a:tr h="493776">
                 <a:tc>
@@ -11576,11 +11580,13 @@
                         </a:defRPr>
                       </a:pPr>
                       <a:r>
+                        <a:rPr dirty="0"/>
                         <a:t>Natural Language English Text</a:t>
                       </a:r>
                     </a:p>
                     <a:p>
                       <a:r>
+                        <a:rPr dirty="0"/>
                         <a:t>(Academic discrete math literature)</a:t>
                       </a:r>
                     </a:p>
@@ -11665,6 +11671,11 @@
                     </a:solidFill>
                   </a:tcPr>
                 </a:tc>
+                <a:extLst>
+                  <a:ext uri="{0D108BD9-81ED-4DB2-BD59-A6C34878D82A}">
+                    <a16:rowId xmlns:a16="http://schemas.microsoft.com/office/drawing/2014/main" val="10001"/>
+                  </a:ext>
+                </a:extLst>
               </a:tr>
               <a:tr h="493776">
                 <a:tc>
@@ -11792,6 +11803,11 @@
                     </a:solidFill>
                   </a:tcPr>
                 </a:tc>
+                <a:extLst>
+                  <a:ext uri="{0D108BD9-81ED-4DB2-BD59-A6C34878D82A}">
+                    <a16:rowId xmlns:a16="http://schemas.microsoft.com/office/drawing/2014/main" val="10002"/>
+                  </a:ext>
+                </a:extLst>
               </a:tr>
               <a:tr h="493776">
                 <a:tc>
@@ -11919,6 +11935,11 @@
                     </a:solidFill>
                   </a:tcPr>
                 </a:tc>
+                <a:extLst>
+                  <a:ext uri="{0D108BD9-81ED-4DB2-BD59-A6C34878D82A}">
+                    <a16:rowId xmlns:a16="http://schemas.microsoft.com/office/drawing/2014/main" val="10003"/>
+                  </a:ext>
+                </a:extLst>
               </a:tr>
               <a:tr h="493776">
                 <a:tc>
@@ -11957,11 +11978,13 @@
                         </a:defRPr>
                       </a:pPr>
                       <a:r>
+                        <a:rPr dirty="0"/>
                         <a:t>Uniform Random Baseline Text</a:t>
                       </a:r>
                     </a:p>
                     <a:p>
                       <a:r>
+                        <a:rPr dirty="0"/>
                         <a:t>(Balanced ASCII symbol generator)</a:t>
                       </a:r>
                     </a:p>
@@ -12031,11 +12054,13 @@
                         </a:defRPr>
                       </a:pPr>
                       <a:r>
+                        <a:rPr dirty="0"/>
                         <a:t>Algorithmic Uniform Generator</a:t>
                       </a:r>
                     </a:p>
                     <a:p>
                       <a:r>
+                        <a:rPr dirty="0"/>
                         <a:t>(sample_uniform.txt)</a:t>
                       </a:r>
                     </a:p>
@@ -12046,6 +12071,11 @@
                     </a:solidFill>
                   </a:tcPr>
                 </a:tc>
+                <a:extLst>
+                  <a:ext uri="{0D108BD9-81ED-4DB2-BD59-A6C34878D82A}">
+                    <a16:rowId xmlns:a16="http://schemas.microsoft.com/office/drawing/2014/main" val="10004"/>
+                  </a:ext>
+                </a:extLst>
               </a:tr>
             </a:tbl>
           </a:graphicData>
@@ -12059,7 +12089,7 @@
         </p:nvSpPr>
         <p:spPr>
           <a:xfrm>
-            <a:off x="731520" y="4114800"/>
+            <a:off x="669341" y="4733544"/>
             <a:ext cx="5120640" cy="2103120"/>
           </a:xfrm>
           <a:prstGeom prst="roundRect">
@@ -12093,6 +12123,7 @@
           <a:lstStyle/>
           <a:p>
             <a:pPr algn="ctr"/>
+            <a:endParaRPr dirty="0"/>
           </a:p>
         </p:txBody>
       </p:sp>
@@ -12104,7 +12135,7 @@
         </p:nvSpPr>
         <p:spPr>
           <a:xfrm>
-            <a:off x="914400" y="4206240"/>
+            <a:off x="731520" y="4919472"/>
             <a:ext cx="4754880" cy="1828800"/>
           </a:xfrm>
           <a:prstGeom prst="rect">
@@ -12126,6 +12157,7 @@
               </a:defRPr>
             </a:pPr>
             <a:r>
+              <a:rPr dirty="0"/>
               <a:t>WHY GENOMIC DNA ACHIEVES 70% COMPRESSION:</a:t>
             </a:r>
           </a:p>
@@ -12137,18 +12169,28 @@
               <a:defRPr sz="950"/>
             </a:pPr>
             <a:r>
+              <a:rPr dirty="0"/>
               <a:t>• DNA features a severely skewed 4-nucleotide alphabet (A, C, G, T).</a:t>
             </a:r>
-            <a:br/>
-            <a:r>
+            <a:br>
+              <a:rPr dirty="0"/>
+            </a:br>
+            <a:r>
+              <a:rPr dirty="0"/>
               <a:t>• Theoretical entropy drops to only H = 2.26 bits/symbol.</a:t>
             </a:r>
-            <a:br/>
-            <a:r>
+            <a:br>
+              <a:rPr dirty="0"/>
+            </a:br>
+            <a:r>
+              <a:rPr dirty="0"/>
               <a:t>• Huffman assigns short 1-to-2 bit paths to frequent bases.</a:t>
             </a:r>
-            <a:br/>
-            <a:r>
+            <a:br>
+              <a:rPr dirty="0"/>
+            </a:br>
+            <a:r>
+              <a:rPr dirty="0"/>
               <a:t>• Result: Massive 3.37x compression ratio (70.37% storage savings)!</a:t>
             </a:r>
           </a:p>
@@ -12162,7 +12204,7 @@
         </p:nvSpPr>
         <p:spPr>
           <a:xfrm>
-            <a:off x="6217920" y="4114800"/>
+            <a:off x="6187745" y="4730496"/>
             <a:ext cx="5242255" cy="2103120"/>
           </a:xfrm>
           <a:prstGeom prst="roundRect">
@@ -12196,6 +12238,7 @@
           <a:lstStyle/>
           <a:p>
             <a:pPr algn="ctr"/>
+            <a:endParaRPr/>
           </a:p>
         </p:txBody>
       </p:sp>
@@ -12207,7 +12250,7 @@
         </p:nvSpPr>
         <p:spPr>
           <a:xfrm>
-            <a:off x="6400800" y="4206240"/>
+            <a:off x="6318504" y="4919472"/>
             <a:ext cx="4846320" cy="1828800"/>
           </a:xfrm>
           <a:prstGeom prst="rect">
@@ -12229,6 +12272,7 @@
               </a:defRPr>
             </a:pPr>
             <a:r>
+              <a:rPr dirty="0"/>
               <a:t>UNIFORM RANDOM CONTROL GROUP:</a:t>
             </a:r>
           </a:p>
@@ -12240,18 +12284,44 @@
               <a:defRPr sz="950"/>
             </a:pPr>
             <a:r>
-              <a:t>• In uniform text, all 76 symbols occur with equal probability (p_i = 1/76).</a:t>
-            </a:r>
-            <a:br/>
-            <a:r>
+              <a:rPr dirty="0"/>
+              <a:t>• In uniform text, all 76 symbols occur with equal probability (</a:t>
+            </a:r>
+            <a:r>
+              <a:rPr dirty="0" err="1"/>
+              <a:t>p_i</a:t>
+            </a:r>
+            <a:r>
+              <a:rPr dirty="0"/>
+              <a:t> = 1/76).</a:t>
+            </a:r>
+            <a:br>
+              <a:rPr dirty="0"/>
+            </a:br>
+            <a:r>
+              <a:rPr dirty="0"/>
               <a:t>• Maximum entropy H = 6.25 bits/symbol.</a:t>
             </a:r>
-            <a:br/>
-            <a:r>
-              <a:t>• Tree leaves sit at nearly identical depths (depth approx log2 76 = 7).</a:t>
-            </a:r>
-            <a:br/>
-            <a:r>
+            <a:br>
+              <a:rPr dirty="0"/>
+            </a:br>
+            <a:r>
+              <a:rPr dirty="0"/>
+              <a:t>• Tree leaves sit at nearly identical depths (depth </a:t>
+            </a:r>
+            <a:r>
+              <a:rPr dirty="0" err="1"/>
+              <a:t>approx</a:t>
+            </a:r>
+            <a:r>
+              <a:rPr dirty="0"/>
+              <a:t> log2 76 = 7).</a:t>
+            </a:r>
+            <a:br>
+              <a:rPr dirty="0"/>
+            </a:br>
+            <a:r>
+              <a:rPr dirty="0"/>
               <a:t>• Proves that prefix compression requires non-uniformity to excel.</a:t>
             </a:r>
           </a:p>
@@ -12266,7 +12336,7 @@
 </file>
 
 <file path=ppt/slides/slide9.xml><?xml version="1.0" encoding="utf-8"?>
-<p:sld xmlns:a="http://schemas.openxmlformats.org/drawingml/2006/main" xmlns:p="http://schemas.openxmlformats.org/presentationml/2006/main" xmlns:r="http://schemas.openxmlformats.org/officeDocument/2006/relationships">
+<p:sld xmlns:a="http://schemas.openxmlformats.org/drawingml/2006/main" xmlns:r="http://schemas.openxmlformats.org/officeDocument/2006/relationships" xmlns:p="http://schemas.openxmlformats.org/presentationml/2006/main">
   <p:cSld>
     <p:spTree>
       <p:nvGrpSpPr>
@@ -12274,7 +12344,14 @@
         <p:cNvGrpSpPr/>
         <p:nvPr/>
       </p:nvGrpSpPr>
-      <p:grpSpPr/>
+      <p:grpSpPr>
+        <a:xfrm>
+          <a:off x="0" y="0"/>
+          <a:ext cx="0" cy="0"/>
+          <a:chOff x="0" y="0"/>
+          <a:chExt cx="0" cy="0"/>
+        </a:xfrm>
+      </p:grpSpPr>
       <p:sp>
         <p:nvSpPr>
           <p:cNvPr id="2" name="Rectangle 1"/>
@@ -12317,6 +12394,7 @@
           <a:lstStyle/>
           <a:p>
             <a:pPr algn="ctr"/>
+            <a:endParaRPr/>
           </a:p>
         </p:txBody>
       </p:sp>
@@ -12483,11 +12561,41 @@
                 <a:tableStyleId>{5C22544A-7EE6-4342-B048-85BDC9FD1C3A}</a:tableStyleId>
               </a:tblPr>
               <a:tblGrid>
-                <a:gridCol w="2286000"/>
-                <a:gridCol w="914400"/>
-                <a:gridCol w="914400"/>
-                <a:gridCol w="914400"/>
-                <a:gridCol w="914400"/>
+                <a:gridCol w="2286000">
+                  <a:extLst>
+                    <a:ext uri="{9D8B030D-6E8A-4147-A177-3AD203B41FA5}">
+                      <a16:colId xmlns:a16="http://schemas.microsoft.com/office/drawing/2014/main" val="20000"/>
+                    </a:ext>
+                  </a:extLst>
+                </a:gridCol>
+                <a:gridCol w="914400">
+                  <a:extLst>
+                    <a:ext uri="{9D8B030D-6E8A-4147-A177-3AD203B41FA5}">
+                      <a16:colId xmlns:a16="http://schemas.microsoft.com/office/drawing/2014/main" val="20001"/>
+                    </a:ext>
+                  </a:extLst>
+                </a:gridCol>
+                <a:gridCol w="914400">
+                  <a:extLst>
+                    <a:ext uri="{9D8B030D-6E8A-4147-A177-3AD203B41FA5}">
+                      <a16:colId xmlns:a16="http://schemas.microsoft.com/office/drawing/2014/main" val="20002"/>
+                    </a:ext>
+                  </a:extLst>
+                </a:gridCol>
+                <a:gridCol w="914400">
+                  <a:extLst>
+                    <a:ext uri="{9D8B030D-6E8A-4147-A177-3AD203B41FA5}">
+                      <a16:colId xmlns:a16="http://schemas.microsoft.com/office/drawing/2014/main" val="20003"/>
+                    </a:ext>
+                  </a:extLst>
+                </a:gridCol>
+                <a:gridCol w="914400">
+                  <a:extLst>
+                    <a:ext uri="{9D8B030D-6E8A-4147-A177-3AD203B41FA5}">
+                      <a16:colId xmlns:a16="http://schemas.microsoft.com/office/drawing/2014/main" val="20004"/>
+                    </a:ext>
+                  </a:extLst>
+                </a:gridCol>
               </a:tblGrid>
               <a:tr h="448887">
                 <a:tc>
@@ -12605,6 +12713,11 @@
                     </a:solidFill>
                   </a:tcPr>
                 </a:tc>
+                <a:extLst>
+                  <a:ext uri="{0D108BD9-81ED-4DB2-BD59-A6C34878D82A}">
+                    <a16:rowId xmlns:a16="http://schemas.microsoft.com/office/drawing/2014/main" val="10000"/>
+                  </a:ext>
+                </a:extLst>
               </a:tr>
               <a:tr h="448887">
                 <a:tc>
@@ -12722,6 +12835,11 @@
                     </a:solidFill>
                   </a:tcPr>
                 </a:tc>
+                <a:extLst>
+                  <a:ext uri="{0D108BD9-81ED-4DB2-BD59-A6C34878D82A}">
+                    <a16:rowId xmlns:a16="http://schemas.microsoft.com/office/drawing/2014/main" val="10001"/>
+                  </a:ext>
+                </a:extLst>
               </a:tr>
               <a:tr h="448887">
                 <a:tc>
@@ -12839,6 +12957,11 @@
                     </a:solidFill>
                   </a:tcPr>
                 </a:tc>
+                <a:extLst>
+                  <a:ext uri="{0D108BD9-81ED-4DB2-BD59-A6C34878D82A}">
+                    <a16:rowId xmlns:a16="http://schemas.microsoft.com/office/drawing/2014/main" val="10002"/>
+                  </a:ext>
+                </a:extLst>
               </a:tr>
               <a:tr h="448887">
                 <a:tc>
@@ -12956,6 +13079,11 @@
                     </a:solidFill>
                   </a:tcPr>
                 </a:tc>
+                <a:extLst>
+                  <a:ext uri="{0D108BD9-81ED-4DB2-BD59-A6C34878D82A}">
+                    <a16:rowId xmlns:a16="http://schemas.microsoft.com/office/drawing/2014/main" val="10003"/>
+                  </a:ext>
+                </a:extLst>
               </a:tr>
               <a:tr h="448887">
                 <a:tc>
@@ -13073,6 +13201,11 @@
                     </a:solidFill>
                   </a:tcPr>
                 </a:tc>
+                <a:extLst>
+                  <a:ext uri="{0D108BD9-81ED-4DB2-BD59-A6C34878D82A}">
+                    <a16:rowId xmlns:a16="http://schemas.microsoft.com/office/drawing/2014/main" val="10004"/>
+                  </a:ext>
+                </a:extLst>
               </a:tr>
               <a:tr h="448887">
                 <a:tc>
@@ -13190,6 +13323,11 @@
                     </a:solidFill>
                   </a:tcPr>
                 </a:tc>
+                <a:extLst>
+                  <a:ext uri="{0D108BD9-81ED-4DB2-BD59-A6C34878D82A}">
+                    <a16:rowId xmlns:a16="http://schemas.microsoft.com/office/drawing/2014/main" val="10005"/>
+                  </a:ext>
+                </a:extLst>
               </a:tr>
               <a:tr h="448887">
                 <a:tc>
@@ -13307,6 +13445,11 @@
                     </a:solidFill>
                   </a:tcPr>
                 </a:tc>
+                <a:extLst>
+                  <a:ext uri="{0D108BD9-81ED-4DB2-BD59-A6C34878D82A}">
+                    <a16:rowId xmlns:a16="http://schemas.microsoft.com/office/drawing/2014/main" val="10006"/>
+                  </a:ext>
+                </a:extLst>
               </a:tr>
               <a:tr h="448887">
                 <a:tc>
@@ -13424,6 +13567,11 @@
                     </a:solidFill>
                   </a:tcPr>
                 </a:tc>
+                <a:extLst>
+                  <a:ext uri="{0D108BD9-81ED-4DB2-BD59-A6C34878D82A}">
+                    <a16:rowId xmlns:a16="http://schemas.microsoft.com/office/drawing/2014/main" val="10007"/>
+                  </a:ext>
+                </a:extLst>
               </a:tr>
               <a:tr h="448887">
                 <a:tc>
@@ -13541,6 +13689,11 @@
                     </a:solidFill>
                   </a:tcPr>
                 </a:tc>
+                <a:extLst>
+                  <a:ext uri="{0D108BD9-81ED-4DB2-BD59-A6C34878D82A}">
+                    <a16:rowId xmlns:a16="http://schemas.microsoft.com/office/drawing/2014/main" val="10008"/>
+                  </a:ext>
+                </a:extLst>
               </a:tr>
               <a:tr h="448887">
                 <a:tc>
@@ -13658,6 +13811,11 @@
                     </a:solidFill>
                   </a:tcPr>
                 </a:tc>
+                <a:extLst>
+                  <a:ext uri="{0D108BD9-81ED-4DB2-BD59-A6C34878D82A}">
+                    <a16:rowId xmlns:a16="http://schemas.microsoft.com/office/drawing/2014/main" val="10009"/>
+                  </a:ext>
+                </a:extLst>
               </a:tr>
               <a:tr h="448890">
                 <a:tc>
@@ -13775,6 +13933,11 @@
                     </a:solidFill>
                   </a:tcPr>
                 </a:tc>
+                <a:extLst>
+                  <a:ext uri="{0D108BD9-81ED-4DB2-BD59-A6C34878D82A}">
+                    <a16:rowId xmlns:a16="http://schemas.microsoft.com/office/drawing/2014/main" val="10010"/>
+                  </a:ext>
+                </a:extLst>
               </a:tr>
             </a:tbl>
           </a:graphicData>
@@ -13789,7 +13952,7 @@
           <p:nvPr/>
         </p:nvPicPr>
         <p:blipFill>
-          <a:blip r:embed="rId2"/>
+          <a:blip r:embed="rId3"/>
           <a:stretch>
             <a:fillRect/>
           </a:stretch>
@@ -14197,44 +14360,44 @@
         <a:sysClr val="window" lastClr="FFFFFF"/>
       </a:lt1>
       <a:dk2>
-        <a:srgbClr val="1F497D"/>
+        <a:srgbClr val="0E2841"/>
       </a:dk2>
       <a:lt2>
-        <a:srgbClr val="EEECE1"/>
+        <a:srgbClr val="E8E8E8"/>
       </a:lt2>
       <a:accent1>
-        <a:srgbClr val="4F81BD"/>
+        <a:srgbClr val="156082"/>
       </a:accent1>
       <a:accent2>
-        <a:srgbClr val="C0504D"/>
+        <a:srgbClr val="E97132"/>
       </a:accent2>
       <a:accent3>
-        <a:srgbClr val="9BBB59"/>
+        <a:srgbClr val="196B24"/>
       </a:accent3>
       <a:accent4>
-        <a:srgbClr val="8064A2"/>
+        <a:srgbClr val="0F9ED5"/>
       </a:accent4>
       <a:accent5>
-        <a:srgbClr val="4BACC6"/>
+        <a:srgbClr val="A02B93"/>
       </a:accent5>
       <a:accent6>
-        <a:srgbClr val="F79646"/>
+        <a:srgbClr val="4EA72E"/>
       </a:accent6>
       <a:hlink>
-        <a:srgbClr val="0000FF"/>
+        <a:srgbClr val="467886"/>
       </a:hlink>
       <a:folHlink>
-        <a:srgbClr val="800080"/>
+        <a:srgbClr val="96607D"/>
       </a:folHlink>
     </a:clrScheme>
     <a:fontScheme name="Office">
       <a:majorFont>
-        <a:latin typeface="Calibri"/>
+        <a:latin typeface="Aptos Display" panose="02110004020202020204"/>
         <a:ea typeface=""/>
         <a:cs typeface=""/>
-        <a:font script="Jpan" typeface="ＭＳ Ｐゴシック"/>
+        <a:font script="Jpan" typeface="游ゴシック Light"/>
         <a:font script="Hang" typeface="맑은 고딕"/>
-        <a:font script="Hans" typeface="宋体"/>
+        <a:font script="Hans" typeface="等线 Light"/>
         <a:font script="Hant" typeface="新細明體"/>
         <a:font script="Arab" typeface="Times New Roman"/>
         <a:font script="Hebr" typeface="Times New Roman"/>
@@ -14262,14 +14425,31 @@
         <a:font script="Viet" typeface="Times New Roman"/>
         <a:font script="Uigh" typeface="Microsoft Uighur"/>
         <a:font script="Geor" typeface="Sylfaen"/>
+        <a:font script="Armn" typeface="Arial"/>
+        <a:font script="Bugi" typeface="Leelawadee UI"/>
+        <a:font script="Bopo" typeface="Microsoft JhengHei"/>
+        <a:font script="Java" typeface="Javanese Text"/>
+        <a:font script="Lisu" typeface="Segoe UI"/>
+        <a:font script="Mymr" typeface="Myanmar Text"/>
+        <a:font script="Nkoo" typeface="Ebrima"/>
+        <a:font script="Olck" typeface="Nirmala UI"/>
+        <a:font script="Osma" typeface="Ebrima"/>
+        <a:font script="Phag" typeface="Phagspa"/>
+        <a:font script="Syrn" typeface="Estrangelo Edessa"/>
+        <a:font script="Syrj" typeface="Estrangelo Edessa"/>
+        <a:font script="Syre" typeface="Estrangelo Edessa"/>
+        <a:font script="Sora" typeface="Nirmala UI"/>
+        <a:font script="Tale" typeface="Microsoft Tai Le"/>
+        <a:font script="Talu" typeface="Microsoft New Tai Lue"/>
+        <a:font script="Tfng" typeface="Ebrima"/>
       </a:majorFont>
       <a:minorFont>
-        <a:latin typeface="Calibri"/>
+        <a:latin typeface="Aptos" panose="02110004020202020204"/>
         <a:ea typeface=""/>
         <a:cs typeface=""/>
-        <a:font script="Jpan" typeface="ＭＳ Ｐゴシック"/>
+        <a:font script="Jpan" typeface="游ゴシック"/>
         <a:font script="Hang" typeface="맑은 고딕"/>
-        <a:font script="Hans" typeface="宋体"/>
+        <a:font script="Hans" typeface="等线"/>
         <a:font script="Hant" typeface="新細明體"/>
         <a:font script="Arab" typeface="Arial"/>
         <a:font script="Hebr" typeface="Arial"/>
@@ -14297,6 +14477,23 @@
         <a:font script="Viet" typeface="Arial"/>
         <a:font script="Uigh" typeface="Microsoft Uighur"/>
         <a:font script="Geor" typeface="Sylfaen"/>
+        <a:font script="Armn" typeface="Arial"/>
+        <a:font script="Bugi" typeface="Leelawadee UI"/>
+        <a:font script="Bopo" typeface="Microsoft JhengHei"/>
+        <a:font script="Java" typeface="Javanese Text"/>
+        <a:font script="Lisu" typeface="Segoe UI"/>
+        <a:font script="Mymr" typeface="Myanmar Text"/>
+        <a:font script="Nkoo" typeface="Ebrima"/>
+        <a:font script="Olck" typeface="Nirmala UI"/>
+        <a:font script="Osma" typeface="Ebrima"/>
+        <a:font script="Phag" typeface="Phagspa"/>
+        <a:font script="Syrn" typeface="Estrangelo Edessa"/>
+        <a:font script="Syrj" typeface="Estrangelo Edessa"/>
+        <a:font script="Syre" typeface="Estrangelo Edessa"/>
+        <a:font script="Sora" typeface="Nirmala UI"/>
+        <a:font script="Tale" typeface="Microsoft Tai Le"/>
+        <a:font script="Talu" typeface="Microsoft New Tai Lue"/>
+        <a:font script="Tfng" typeface="Ebrima"/>
       </a:minorFont>
     </a:fontScheme>
     <a:fmtScheme name="Office">
@@ -14308,180 +14505,136 @@
           <a:gsLst>
             <a:gs pos="0">
               <a:schemeClr val="phClr">
-                <a:tint val="50000"/>
-                <a:satMod val="300000"/>
+                <a:lumMod val="110000"/>
+                <a:satMod val="105000"/>
+                <a:tint val="67000"/>
               </a:schemeClr>
             </a:gs>
-            <a:gs pos="35000">
+            <a:gs pos="50000">
               <a:schemeClr val="phClr">
-                <a:tint val="37000"/>
-                <a:satMod val="300000"/>
+                <a:lumMod val="105000"/>
+                <a:satMod val="103000"/>
+                <a:tint val="73000"/>
               </a:schemeClr>
             </a:gs>
             <a:gs pos="100000">
               <a:schemeClr val="phClr">
-                <a:tint val="15000"/>
-                <a:satMod val="350000"/>
+                <a:lumMod val="105000"/>
+                <a:satMod val="109000"/>
+                <a:tint val="81000"/>
               </a:schemeClr>
             </a:gs>
           </a:gsLst>
-          <a:lin ang="16200000" scaled="1"/>
+          <a:lin ang="5400000" scaled="0"/>
         </a:gradFill>
         <a:gradFill rotWithShape="1">
           <a:gsLst>
             <a:gs pos="0">
               <a:schemeClr val="phClr">
-                <a:tint val="100000"/>
+                <a:satMod val="103000"/>
+                <a:lumMod val="102000"/>
+                <a:tint val="94000"/>
+              </a:schemeClr>
+            </a:gs>
+            <a:gs pos="50000">
+              <a:schemeClr val="phClr">
+                <a:satMod val="110000"/>
+                <a:lumMod val="100000"/>
                 <a:shade val="100000"/>
-                <a:satMod val="130000"/>
               </a:schemeClr>
             </a:gs>
             <a:gs pos="100000">
               <a:schemeClr val="phClr">
-                <a:tint val="50000"/>
-                <a:shade val="100000"/>
-                <a:satMod val="350000"/>
+                <a:lumMod val="99000"/>
+                <a:satMod val="120000"/>
+                <a:shade val="78000"/>
               </a:schemeClr>
             </a:gs>
           </a:gsLst>
-          <a:lin ang="16200000" scaled="0"/>
+          <a:lin ang="5400000" scaled="0"/>
         </a:gradFill>
       </a:fillStyleLst>
       <a:lnStyleLst>
-        <a:ln w="9525" cap="flat" cmpd="sng" algn="ctr">
+        <a:ln w="12700" cap="flat" cmpd="sng" algn="ctr">
           <a:solidFill>
-            <a:schemeClr val="phClr">
-              <a:shade val="95000"/>
-              <a:satMod val="105000"/>
-            </a:schemeClr>
+            <a:schemeClr val="phClr"/>
           </a:solidFill>
           <a:prstDash val="solid"/>
+          <a:miter lim="800000"/>
+        </a:ln>
+        <a:ln w="19050" cap="flat" cmpd="sng" algn="ctr">
+          <a:solidFill>
+            <a:schemeClr val="phClr"/>
+          </a:solidFill>
+          <a:prstDash val="solid"/>
+          <a:miter lim="800000"/>
         </a:ln>
         <a:ln w="25400" cap="flat" cmpd="sng" algn="ctr">
           <a:solidFill>
             <a:schemeClr val="phClr"/>
           </a:solidFill>
           <a:prstDash val="solid"/>
-        </a:ln>
-        <a:ln w="38100" cap="flat" cmpd="sng" algn="ctr">
-          <a:solidFill>
-            <a:schemeClr val="phClr"/>
-          </a:solidFill>
-          <a:prstDash val="solid"/>
+          <a:miter lim="800000"/>
         </a:ln>
       </a:lnStyleLst>
       <a:effectStyleLst>
         <a:effectStyle>
+          <a:effectLst/>
+        </a:effectStyle>
+        <a:effectStyle>
+          <a:effectLst/>
+        </a:effectStyle>
+        <a:effectStyle>
           <a:effectLst>
-            <a:outerShdw blurRad="40000" dist="20000" dir="5400000" rotWithShape="0">
+            <a:outerShdw blurRad="57150" dist="19050" dir="5400000" algn="ctr" rotWithShape="0">
               <a:srgbClr val="000000">
-                <a:alpha val="38000"/>
+                <a:alpha val="63000"/>
               </a:srgbClr>
             </a:outerShdw>
           </a:effectLst>
-        </a:effectStyle>
-        <a:effectStyle>
-          <a:effectLst>
-            <a:outerShdw blurRad="40000" dist="23000" dir="5400000" rotWithShape="0">
-              <a:srgbClr val="000000">
-                <a:alpha val="35000"/>
-              </a:srgbClr>
-            </a:outerShdw>
-          </a:effectLst>
-        </a:effectStyle>
-        <a:effectStyle>
-          <a:effectLst>
-            <a:outerShdw blurRad="40000" dist="23000" dir="5400000" rotWithShape="0">
-              <a:srgbClr val="000000">
-                <a:alpha val="35000"/>
-              </a:srgbClr>
-            </a:outerShdw>
-          </a:effectLst>
-          <a:scene3d>
-            <a:camera prst="orthographicFront">
-              <a:rot lat="0" lon="0" rev="0"/>
-            </a:camera>
-            <a:lightRig rig="threePt" dir="t">
-              <a:rot lat="0" lon="0" rev="1200000"/>
-            </a:lightRig>
-          </a:scene3d>
-          <a:sp3d>
-            <a:bevelT w="63500" h="25400"/>
-          </a:sp3d>
         </a:effectStyle>
       </a:effectStyleLst>
       <a:bgFillStyleLst>
         <a:solidFill>
           <a:schemeClr val="phClr"/>
         </a:solidFill>
+        <a:solidFill>
+          <a:schemeClr val="phClr">
+            <a:tint val="95000"/>
+            <a:satMod val="170000"/>
+          </a:schemeClr>
+        </a:solidFill>
         <a:gradFill rotWithShape="1">
           <a:gsLst>
             <a:gs pos="0">
               <a:schemeClr val="phClr">
-                <a:tint val="40000"/>
-                <a:satMod val="350000"/>
+                <a:tint val="93000"/>
+                <a:satMod val="150000"/>
+                <a:shade val="98000"/>
+                <a:lumMod val="102000"/>
               </a:schemeClr>
             </a:gs>
-            <a:gs pos="40000">
+            <a:gs pos="50000">
               <a:schemeClr val="phClr">
-                <a:tint val="45000"/>
-                <a:shade val="99000"/>
-                <a:satMod val="350000"/>
+                <a:tint val="98000"/>
+                <a:satMod val="130000"/>
+                <a:shade val="90000"/>
+                <a:lumMod val="103000"/>
               </a:schemeClr>
             </a:gs>
             <a:gs pos="100000">
               <a:schemeClr val="phClr">
-                <a:shade val="20000"/>
-                <a:satMod val="255000"/>
+                <a:shade val="63000"/>
+                <a:satMod val="120000"/>
               </a:schemeClr>
             </a:gs>
           </a:gsLst>
-          <a:path path="circle">
-            <a:fillToRect l="50000" t="-80000" r="50000" b="180000"/>
-          </a:path>
-        </a:gradFill>
-        <a:gradFill rotWithShape="1">
-          <a:gsLst>
-            <a:gs pos="0">
-              <a:schemeClr val="phClr">
-                <a:tint val="80000"/>
-                <a:satMod val="300000"/>
-              </a:schemeClr>
-            </a:gs>
-            <a:gs pos="100000">
-              <a:schemeClr val="phClr">
-                <a:shade val="30000"/>
-                <a:satMod val="200000"/>
-              </a:schemeClr>
-            </a:gs>
-          </a:gsLst>
-          <a:path path="circle">
-            <a:fillToRect l="50000" t="50000" r="50000" b="50000"/>
-          </a:path>
+          <a:lin ang="5400000" scaled="0"/>
         </a:gradFill>
       </a:bgFillStyleLst>
     </a:fmtScheme>
   </a:themeElements>
   <a:objectDefaults>
-    <a:spDef>
-      <a:spPr/>
-      <a:bodyPr/>
-      <a:lstStyle/>
-      <a:style>
-        <a:lnRef idx="1">
-          <a:schemeClr val="accent1"/>
-        </a:lnRef>
-        <a:fillRef idx="3">
-          <a:schemeClr val="accent1"/>
-        </a:fillRef>
-        <a:effectRef idx="2">
-          <a:schemeClr val="accent1"/>
-        </a:effectRef>
-        <a:fontRef idx="minor">
-          <a:schemeClr val="lt1"/>
-        </a:fontRef>
-      </a:style>
-    </a:spDef>
     <a:lnDef>
       <a:spPr/>
       <a:bodyPr/>
@@ -14503,5 +14656,10 @@
     </a:lnDef>
   </a:objectDefaults>
   <a:extraClrSchemeLst/>
+  <a:extLst>
+    <a:ext uri="{05A4C25C-085E-4340-85A3-A5531E510DB2}">
+      <thm15:themeFamily xmlns:thm15="http://schemas.microsoft.com/office/thememl/2012/main" name="Office Theme" id="{2E142A2C-CD16-42D6-873A-C26D2A0506FA}" vid="{1BDDFF52-6CD6-40A5-AB3C-68EB2F1E4D0A}"/>
+    </a:ext>
+  </a:extLst>
 </a:theme>
 </file>
</xml_diff>